<commit_message>
adding presentation + disc related files
</commit_message>
<xml_diff>
--- a/final presentation Hayk.pptx
+++ b/final presentation Hayk.pptx
@@ -6,25 +6,22 @@
   </p:sldMasterIdLst>
   <p:sldIdLst>
     <p:sldId id="256" r:id="rId2"/>
-    <p:sldId id="264" r:id="rId3"/>
-    <p:sldId id="269" r:id="rId4"/>
-    <p:sldId id="261" r:id="rId5"/>
-    <p:sldId id="274" r:id="rId6"/>
-    <p:sldId id="259" r:id="rId7"/>
-    <p:sldId id="257" r:id="rId8"/>
-    <p:sldId id="258" r:id="rId9"/>
-    <p:sldId id="262" r:id="rId10"/>
-    <p:sldId id="271" r:id="rId11"/>
-    <p:sldId id="266" r:id="rId12"/>
-    <p:sldId id="272" r:id="rId13"/>
-    <p:sldId id="276" r:id="rId14"/>
-    <p:sldId id="275" r:id="rId15"/>
-    <p:sldId id="273" r:id="rId16"/>
-    <p:sldId id="267" r:id="rId17"/>
-    <p:sldId id="270" r:id="rId18"/>
-    <p:sldId id="265" r:id="rId19"/>
-    <p:sldId id="268" r:id="rId20"/>
-    <p:sldId id="263" r:id="rId21"/>
+    <p:sldId id="261" r:id="rId3"/>
+    <p:sldId id="274" r:id="rId4"/>
+    <p:sldId id="257" r:id="rId5"/>
+    <p:sldId id="262" r:id="rId6"/>
+    <p:sldId id="271" r:id="rId7"/>
+    <p:sldId id="266" r:id="rId8"/>
+    <p:sldId id="272" r:id="rId9"/>
+    <p:sldId id="276" r:id="rId10"/>
+    <p:sldId id="275" r:id="rId11"/>
+    <p:sldId id="267" r:id="rId12"/>
+    <p:sldId id="270" r:id="rId13"/>
+    <p:sldId id="265" r:id="rId14"/>
+    <p:sldId id="268" r:id="rId15"/>
+    <p:sldId id="279" r:id="rId16"/>
+    <p:sldId id="277" r:id="rId17"/>
+    <p:sldId id="278" r:id="rId18"/>
   </p:sldIdLst>
   <p:sldSz cx="12192000" cy="6858000"/>
   <p:notesSz cx="6858000" cy="9144000"/>
@@ -262,7 +259,7 @@
           <a:p>
             <a:fld id="{26B45A88-84CD-47B4-B068-1CCEBD78BFD4}" type="datetimeFigureOut">
               <a:rPr lang="ru-RU" smtClean="0"/>
-              <a:t>28.04.2026</a:t>
+              <a:t>14.05.2026</a:t>
             </a:fld>
             <a:endParaRPr lang="ru-RU"/>
           </a:p>
@@ -432,7 +429,7 @@
           <a:p>
             <a:fld id="{26B45A88-84CD-47B4-B068-1CCEBD78BFD4}" type="datetimeFigureOut">
               <a:rPr lang="ru-RU" smtClean="0"/>
-              <a:t>28.04.2026</a:t>
+              <a:t>14.05.2026</a:t>
             </a:fld>
             <a:endParaRPr lang="ru-RU"/>
           </a:p>
@@ -612,7 +609,7 @@
           <a:p>
             <a:fld id="{26B45A88-84CD-47B4-B068-1CCEBD78BFD4}" type="datetimeFigureOut">
               <a:rPr lang="ru-RU" smtClean="0"/>
-              <a:t>28.04.2026</a:t>
+              <a:t>14.05.2026</a:t>
             </a:fld>
             <a:endParaRPr lang="ru-RU"/>
           </a:p>
@@ -782,7 +779,7 @@
           <a:p>
             <a:fld id="{26B45A88-84CD-47B4-B068-1CCEBD78BFD4}" type="datetimeFigureOut">
               <a:rPr lang="ru-RU" smtClean="0"/>
-              <a:t>28.04.2026</a:t>
+              <a:t>14.05.2026</a:t>
             </a:fld>
             <a:endParaRPr lang="ru-RU"/>
           </a:p>
@@ -1028,7 +1025,7 @@
           <a:p>
             <a:fld id="{26B45A88-84CD-47B4-B068-1CCEBD78BFD4}" type="datetimeFigureOut">
               <a:rPr lang="ru-RU" smtClean="0"/>
-              <a:t>28.04.2026</a:t>
+              <a:t>14.05.2026</a:t>
             </a:fld>
             <a:endParaRPr lang="ru-RU"/>
           </a:p>
@@ -1260,7 +1257,7 @@
           <a:p>
             <a:fld id="{26B45A88-84CD-47B4-B068-1CCEBD78BFD4}" type="datetimeFigureOut">
               <a:rPr lang="ru-RU" smtClean="0"/>
-              <a:t>28.04.2026</a:t>
+              <a:t>14.05.2026</a:t>
             </a:fld>
             <a:endParaRPr lang="ru-RU"/>
           </a:p>
@@ -1627,7 +1624,7 @@
           <a:p>
             <a:fld id="{26B45A88-84CD-47B4-B068-1CCEBD78BFD4}" type="datetimeFigureOut">
               <a:rPr lang="ru-RU" smtClean="0"/>
-              <a:t>28.04.2026</a:t>
+              <a:t>14.05.2026</a:t>
             </a:fld>
             <a:endParaRPr lang="ru-RU"/>
           </a:p>
@@ -1745,7 +1742,7 @@
           <a:p>
             <a:fld id="{26B45A88-84CD-47B4-B068-1CCEBD78BFD4}" type="datetimeFigureOut">
               <a:rPr lang="ru-RU" smtClean="0"/>
-              <a:t>28.04.2026</a:t>
+              <a:t>14.05.2026</a:t>
             </a:fld>
             <a:endParaRPr lang="ru-RU"/>
           </a:p>
@@ -1840,7 +1837,7 @@
           <a:p>
             <a:fld id="{26B45A88-84CD-47B4-B068-1CCEBD78BFD4}" type="datetimeFigureOut">
               <a:rPr lang="ru-RU" smtClean="0"/>
-              <a:t>28.04.2026</a:t>
+              <a:t>14.05.2026</a:t>
             </a:fld>
             <a:endParaRPr lang="ru-RU"/>
           </a:p>
@@ -2117,7 +2114,7 @@
           <a:p>
             <a:fld id="{26B45A88-84CD-47B4-B068-1CCEBD78BFD4}" type="datetimeFigureOut">
               <a:rPr lang="ru-RU" smtClean="0"/>
-              <a:t>28.04.2026</a:t>
+              <a:t>14.05.2026</a:t>
             </a:fld>
             <a:endParaRPr lang="ru-RU"/>
           </a:p>
@@ -2370,7 +2367,7 @@
           <a:p>
             <a:fld id="{26B45A88-84CD-47B4-B068-1CCEBD78BFD4}" type="datetimeFigureOut">
               <a:rPr lang="ru-RU" smtClean="0"/>
-              <a:t>28.04.2026</a:t>
+              <a:t>14.05.2026</a:t>
             </a:fld>
             <a:endParaRPr lang="ru-RU"/>
           </a:p>
@@ -2583,7 +2580,7 @@
           <a:p>
             <a:fld id="{26B45A88-84CD-47B4-B068-1CCEBD78BFD4}" type="datetimeFigureOut">
               <a:rPr lang="ru-RU" smtClean="0"/>
-              <a:t>28.04.2026</a:t>
+              <a:t>14.05.2026</a:t>
             </a:fld>
             <a:endParaRPr lang="ru-RU"/>
           </a:p>
@@ -3145,6 +3142,1597 @@
           <a:chExt cx="0" cy="0"/>
         </a:xfrm>
       </p:grpSpPr>
+      <p:pic>
+        <p:nvPicPr>
+          <p:cNvPr id="4" name="Picture 3"/>
+          <p:cNvPicPr/>
+          <p:nvPr/>
+        </p:nvPicPr>
+        <p:blipFill>
+          <a:blip r:embed="rId2"/>
+          <a:stretch>
+            <a:fillRect/>
+          </a:stretch>
+        </p:blipFill>
+        <p:spPr>
+          <a:xfrm>
+            <a:off x="3422332" y="1609725"/>
+            <a:ext cx="5347335" cy="3638550"/>
+          </a:xfrm>
+          <a:prstGeom prst="rect">
+            <a:avLst/>
+          </a:prstGeom>
+        </p:spPr>
+      </p:pic>
+      <p:pic>
+        <p:nvPicPr>
+          <p:cNvPr id="5" name="Picture 4"/>
+          <p:cNvPicPr/>
+          <p:nvPr/>
+        </p:nvPicPr>
+        <p:blipFill>
+          <a:blip r:embed="rId2"/>
+          <a:stretch>
+            <a:fillRect/>
+          </a:stretch>
+        </p:blipFill>
+        <p:spPr>
+          <a:xfrm>
+            <a:off x="919765" y="0"/>
+            <a:ext cx="10078745" cy="6858000"/>
+          </a:xfrm>
+          <a:prstGeom prst="rect">
+            <a:avLst/>
+          </a:prstGeom>
+        </p:spPr>
+      </p:pic>
+    </p:spTree>
+    <p:extLst>
+      <p:ext uri="{BB962C8B-B14F-4D97-AF65-F5344CB8AC3E}">
+        <p14:creationId xmlns:p14="http://schemas.microsoft.com/office/powerpoint/2010/main" val="3689277141"/>
+      </p:ext>
+    </p:extLst>
+  </p:cSld>
+  <p:clrMapOvr>
+    <a:masterClrMapping/>
+  </p:clrMapOvr>
+  <p:timing>
+    <p:tnLst>
+      <p:par>
+        <p:cTn id="1" dur="indefinite" restart="never" nodeType="tmRoot"/>
+      </p:par>
+    </p:tnLst>
+  </p:timing>
+</p:sld>
+</file>
+
+<file path=ppt/slides/slide11.xml><?xml version="1.0" encoding="utf-8"?>
+<p:sld xmlns:a="http://schemas.openxmlformats.org/drawingml/2006/main" xmlns:r="http://schemas.openxmlformats.org/officeDocument/2006/relationships" xmlns:p="http://schemas.openxmlformats.org/presentationml/2006/main">
+  <p:cSld>
+    <p:spTree>
+      <p:nvGrpSpPr>
+        <p:cNvPr id="1" name=""/>
+        <p:cNvGrpSpPr/>
+        <p:nvPr/>
+      </p:nvGrpSpPr>
+      <p:grpSpPr>
+        <a:xfrm>
+          <a:off x="0" y="0"/>
+          <a:ext cx="0" cy="0"/>
+          <a:chOff x="0" y="0"/>
+          <a:chExt cx="0" cy="0"/>
+        </a:xfrm>
+      </p:grpSpPr>
+      <p:sp>
+        <p:nvSpPr>
+          <p:cNvPr id="2" name="Title 1"/>
+          <p:cNvSpPr>
+            <a:spLocks noGrp="1"/>
+          </p:cNvSpPr>
+          <p:nvPr>
+            <p:ph type="title"/>
+          </p:nvPr>
+        </p:nvSpPr>
+        <p:spPr>
+          <a:xfrm>
+            <a:off x="838200" y="514488"/>
+            <a:ext cx="10515600" cy="1325563"/>
+          </a:xfrm>
+        </p:spPr>
+        <p:txBody>
+          <a:bodyPr/>
+          <a:lstStyle/>
+          <a:p>
+            <a:pPr algn="ctr"/>
+            <a:r>
+              <a:rPr lang="hy-AM" dirty="0"/>
+              <a:t>EAD </a:t>
+            </a:r>
+            <a:r>
+              <a:rPr lang="hy-AM" dirty="0" smtClean="0"/>
+              <a:t>Գործակցի Բանաձևը</a:t>
+            </a:r>
+            <a:endParaRPr lang="ru-RU" dirty="0"/>
+          </a:p>
+        </p:txBody>
+      </p:sp>
+      <mc:AlternateContent xmlns:mc="http://schemas.openxmlformats.org/markup-compatibility/2006" xmlns:a14="http://schemas.microsoft.com/office/drawing/2010/main">
+        <mc:Choice Requires="a14">
+          <p:sp>
+            <p:nvSpPr>
+              <p:cNvPr id="3" name="Content Placeholder 2"/>
+              <p:cNvSpPr>
+                <a:spLocks noGrp="1"/>
+              </p:cNvSpPr>
+              <p:nvPr>
+                <p:ph idx="1"/>
+              </p:nvPr>
+            </p:nvSpPr>
+            <p:spPr>
+              <a:xfrm>
+                <a:off x="950495" y="1954430"/>
+                <a:ext cx="10515600" cy="757777"/>
+              </a:xfrm>
+            </p:spPr>
+            <p:txBody>
+              <a:bodyPr>
+                <a:normAutofit/>
+              </a:bodyPr>
+              <a:lstStyle/>
+              <a:p>
+                <a:pPr marL="0" indent="0">
+                  <a:buNone/>
+                </a:pPr>
+                <a14:m>
+                  <m:oMathPara xmlns:m="http://schemas.openxmlformats.org/officeDocument/2006/math">
+                    <m:oMathParaPr>
+                      <m:jc m:val="centerGroup"/>
+                    </m:oMathParaPr>
+                    <m:oMath xmlns:m="http://schemas.openxmlformats.org/officeDocument/2006/math">
+                      <m:r>
+                        <a:rPr lang="hy-AM" sz="3200" i="1" smtClean="0">
+                          <a:latin typeface="Cambria Math" panose="02040503050406030204" pitchFamily="18" charset="0"/>
+                        </a:rPr>
+                        <m:t>𝐸𝐴𝐷</m:t>
+                      </m:r>
+                      <m:r>
+                        <a:rPr lang="hy-AM" sz="3200" i="1" smtClean="0">
+                          <a:latin typeface="Cambria Math" panose="02040503050406030204" pitchFamily="18" charset="0"/>
+                        </a:rPr>
+                        <m:t>=</m:t>
+                      </m:r>
+                      <m:r>
+                        <a:rPr lang="en-US" sz="3200" i="1">
+                          <a:latin typeface="Cambria Math" panose="02040503050406030204" pitchFamily="18" charset="0"/>
+                        </a:rPr>
+                        <m:t>𝑂𝑢𝑡𝑠𝑡𝑎𝑛𝑑𝑖𝑛𝑔</m:t>
+                      </m:r>
+                      <m:r>
+                        <a:rPr lang="en-US" sz="3200" i="1">
+                          <a:latin typeface="Cambria Math" panose="02040503050406030204" pitchFamily="18" charset="0"/>
+                        </a:rPr>
+                        <m:t> </m:t>
+                      </m:r>
+                      <m:r>
+                        <a:rPr lang="en-US" sz="3200" i="1">
+                          <a:latin typeface="Cambria Math" panose="02040503050406030204" pitchFamily="18" charset="0"/>
+                        </a:rPr>
+                        <m:t>𝐵𝑎𝑙𝑎𝑛𝑐𝑒</m:t>
+                      </m:r>
+                      <m:r>
+                        <a:rPr lang="en-US" sz="3200" i="1">
+                          <a:latin typeface="Cambria Math" panose="02040503050406030204" pitchFamily="18" charset="0"/>
+                        </a:rPr>
+                        <m:t> + (</m:t>
+                      </m:r>
+                      <m:r>
+                        <a:rPr lang="en-US" sz="3200" i="1">
+                          <a:latin typeface="Cambria Math" panose="02040503050406030204" pitchFamily="18" charset="0"/>
+                        </a:rPr>
+                        <m:t>𝐶𝑟𝑒𝑑𝑖𝑡</m:t>
+                      </m:r>
+                      <m:r>
+                        <a:rPr lang="en-US" sz="3200" i="1">
+                          <a:latin typeface="Cambria Math" panose="02040503050406030204" pitchFamily="18" charset="0"/>
+                        </a:rPr>
+                        <m:t> </m:t>
+                      </m:r>
+                      <m:r>
+                        <a:rPr lang="en-US" sz="3200" i="1">
+                          <a:latin typeface="Cambria Math" panose="02040503050406030204" pitchFamily="18" charset="0"/>
+                        </a:rPr>
+                        <m:t>𝐿𝑖𝑚𝑖𝑡</m:t>
+                      </m:r>
+                      <m:r>
+                        <a:rPr lang="en-US" sz="3200" i="1">
+                          <a:latin typeface="Cambria Math" panose="02040503050406030204" pitchFamily="18" charset="0"/>
+                        </a:rPr>
+                        <m:t> </m:t>
+                      </m:r>
+                      <m:r>
+                        <a:rPr lang="en-US" sz="3200" i="1">
+                          <a:latin typeface="Cambria Math" panose="02040503050406030204" pitchFamily="18" charset="0"/>
+                        </a:rPr>
+                        <m:t>𝑥</m:t>
+                      </m:r>
+                      <m:r>
+                        <a:rPr lang="en-US" sz="3200" i="1">
+                          <a:latin typeface="Cambria Math" panose="02040503050406030204" pitchFamily="18" charset="0"/>
+                        </a:rPr>
+                        <m:t> </m:t>
+                      </m:r>
+                      <m:r>
+                        <a:rPr lang="en-US" sz="3200" i="1">
+                          <a:latin typeface="Cambria Math" panose="02040503050406030204" pitchFamily="18" charset="0"/>
+                        </a:rPr>
+                        <m:t>𝐶𝐶𝐹</m:t>
+                      </m:r>
+                      <m:r>
+                        <a:rPr lang="en-US" sz="3200" i="1">
+                          <a:latin typeface="Cambria Math" panose="02040503050406030204" pitchFamily="18" charset="0"/>
+                        </a:rPr>
+                        <m:t>)</m:t>
+                      </m:r>
+                    </m:oMath>
+                  </m:oMathPara>
+                </a14:m>
+                <a:endParaRPr lang="ru-RU" sz="3200" dirty="0"/>
+              </a:p>
+            </p:txBody>
+          </p:sp>
+        </mc:Choice>
+        <mc:Fallback xmlns="">
+          <p:sp>
+            <p:nvSpPr>
+              <p:cNvPr id="3" name="Content Placeholder 2"/>
+              <p:cNvSpPr>
+                <a:spLocks noGrp="1" noRot="1" noChangeAspect="1" noMove="1" noResize="1" noEditPoints="1" noAdjustHandles="1" noChangeArrowheads="1" noChangeShapeType="1" noTextEdit="1"/>
+              </p:cNvSpPr>
+              <p:nvPr>
+                <p:ph idx="1"/>
+              </p:nvPr>
+            </p:nvSpPr>
+            <p:spPr>
+              <a:xfrm>
+                <a:off x="950495" y="1954430"/>
+                <a:ext cx="10515600" cy="757777"/>
+              </a:xfrm>
+              <a:blipFill>
+                <a:blip r:embed="rId2"/>
+                <a:stretch>
+                  <a:fillRect/>
+                </a:stretch>
+              </a:blipFill>
+            </p:spPr>
+            <p:txBody>
+              <a:bodyPr/>
+              <a:lstStyle/>
+              <a:p>
+                <a:r>
+                  <a:rPr lang="ru-RU">
+                    <a:noFill/>
+                  </a:rPr>
+                  <a:t> </a:t>
+                </a:r>
+              </a:p>
+            </p:txBody>
+          </p:sp>
+        </mc:Fallback>
+      </mc:AlternateContent>
+      <p:sp>
+        <p:nvSpPr>
+          <p:cNvPr id="4" name="TextBox 3"/>
+          <p:cNvSpPr txBox="1"/>
+          <p:nvPr/>
+        </p:nvSpPr>
+        <p:spPr>
+          <a:xfrm>
+            <a:off x="1315453" y="2826586"/>
+            <a:ext cx="10038347" cy="2246769"/>
+          </a:xfrm>
+          <a:prstGeom prst="rect">
+            <a:avLst/>
+          </a:prstGeom>
+          <a:noFill/>
+        </p:spPr>
+        <p:txBody>
+          <a:bodyPr wrap="square" rtlCol="0">
+            <a:spAutoFit/>
+          </a:bodyPr>
+          <a:lstStyle/>
+          <a:p>
+            <a:r>
+              <a:rPr lang="en-US" sz="2800" dirty="0"/>
+              <a:t>•	Outstanding Balance - </a:t>
+            </a:r>
+            <a:r>
+              <a:rPr lang="hy-AM" sz="2800" dirty="0"/>
+              <a:t>ընթացիկ պարտք,</a:t>
+            </a:r>
+          </a:p>
+          <a:p>
+            <a:r>
+              <a:rPr lang="hy-AM" sz="2800" dirty="0"/>
+              <a:t>•	</a:t>
+            </a:r>
+            <a:r>
+              <a:rPr lang="en-US" sz="2800" dirty="0"/>
+              <a:t>Credit Limit - </a:t>
+            </a:r>
+            <a:r>
+              <a:rPr lang="hy-AM" sz="2800" dirty="0"/>
+              <a:t>վարկային սահմանաչափ,</a:t>
+            </a:r>
+          </a:p>
+          <a:p>
+            <a:r>
+              <a:rPr lang="hy-AM" sz="2800" dirty="0"/>
+              <a:t>•	</a:t>
+            </a:r>
+            <a:r>
+              <a:rPr lang="en-US" sz="2800" dirty="0"/>
+              <a:t>CCF </a:t>
+            </a:r>
+            <a:r>
+              <a:rPr lang="en-US" sz="2800" dirty="0" smtClean="0"/>
+              <a:t>- </a:t>
+            </a:r>
+            <a:r>
+              <a:rPr lang="hy-AM" sz="2800" dirty="0"/>
+              <a:t>վարկային </a:t>
+            </a:r>
+            <a:r>
+              <a:rPr lang="hy-AM" sz="2800" dirty="0" smtClean="0"/>
+              <a:t>փոխակերպման</a:t>
+            </a:r>
+            <a:r>
+              <a:rPr lang="en-US" sz="2800" dirty="0" smtClean="0"/>
+              <a:t> </a:t>
+            </a:r>
+            <a:r>
+              <a:rPr lang="hy-AM" sz="2800" dirty="0" smtClean="0"/>
+              <a:t>գործակից </a:t>
+            </a:r>
+            <a:endParaRPr lang="en-US" sz="2800" dirty="0" smtClean="0"/>
+          </a:p>
+          <a:p>
+            <a:r>
+              <a:rPr lang="hy-AM" sz="2800" dirty="0" smtClean="0"/>
+              <a:t>•	Գործնական նշանակությունը.</a:t>
+            </a:r>
+          </a:p>
+          <a:p>
+            <a:endParaRPr lang="ru-RU" sz="2800" dirty="0"/>
+          </a:p>
+        </p:txBody>
+      </p:sp>
+    </p:spTree>
+    <p:extLst>
+      <p:ext uri="{BB962C8B-B14F-4D97-AF65-F5344CB8AC3E}">
+        <p14:creationId xmlns:p14="http://schemas.microsoft.com/office/powerpoint/2010/main" val="1495527178"/>
+      </p:ext>
+    </p:extLst>
+  </p:cSld>
+  <p:clrMapOvr>
+    <a:masterClrMapping/>
+  </p:clrMapOvr>
+  <p:timing>
+    <p:tnLst>
+      <p:par>
+        <p:cTn id="1" dur="indefinite" restart="never" nodeType="tmRoot"/>
+      </p:par>
+    </p:tnLst>
+  </p:timing>
+</p:sld>
+</file>
+
+<file path=ppt/slides/slide12.xml><?xml version="1.0" encoding="utf-8"?>
+<p:sld xmlns:a="http://schemas.openxmlformats.org/drawingml/2006/main" xmlns:r="http://schemas.openxmlformats.org/officeDocument/2006/relationships" xmlns:p="http://schemas.openxmlformats.org/presentationml/2006/main">
+  <p:cSld>
+    <p:spTree>
+      <p:nvGrpSpPr>
+        <p:cNvPr id="1" name=""/>
+        <p:cNvGrpSpPr/>
+        <p:nvPr/>
+      </p:nvGrpSpPr>
+      <p:grpSpPr>
+        <a:xfrm>
+          <a:off x="0" y="0"/>
+          <a:ext cx="0" cy="0"/>
+          <a:chOff x="0" y="0"/>
+          <a:chExt cx="0" cy="0"/>
+        </a:xfrm>
+      </p:grpSpPr>
+      <p:sp>
+        <p:nvSpPr>
+          <p:cNvPr id="4" name="Title 1"/>
+          <p:cNvSpPr>
+            <a:spLocks noGrp="1"/>
+          </p:cNvSpPr>
+          <p:nvPr>
+            <p:ph type="title"/>
+          </p:nvPr>
+        </p:nvSpPr>
+        <p:spPr>
+          <a:xfrm>
+            <a:off x="838200" y="651888"/>
+            <a:ext cx="10515600" cy="1325563"/>
+          </a:xfrm>
+        </p:spPr>
+        <p:txBody>
+          <a:bodyPr/>
+          <a:lstStyle/>
+          <a:p>
+            <a:pPr algn="ctr"/>
+            <a:r>
+              <a:rPr lang="en-US" dirty="0" smtClean="0"/>
+              <a:t>LGD</a:t>
+            </a:r>
+            <a:r>
+              <a:rPr lang="hy-AM" dirty="0" smtClean="0"/>
+              <a:t> </a:t>
+            </a:r>
+            <a:r>
+              <a:rPr lang="en-US" dirty="0" smtClean="0"/>
+              <a:t>(</a:t>
+            </a:r>
+            <a:r>
+              <a:rPr lang="hy-AM" dirty="0"/>
+              <a:t>Կորուստը չվճարման դեպքում</a:t>
+            </a:r>
+            <a:r>
+              <a:rPr lang="en-US" dirty="0" smtClean="0"/>
+              <a:t>) </a:t>
+            </a:r>
+            <a:r>
+              <a:rPr lang="hy-AM" dirty="0" smtClean="0"/>
+              <a:t>Գործակցի Բանաձևը</a:t>
+            </a:r>
+            <a:endParaRPr lang="ru-RU" dirty="0"/>
+          </a:p>
+        </p:txBody>
+      </p:sp>
+      <mc:AlternateContent xmlns:mc="http://schemas.openxmlformats.org/markup-compatibility/2006" xmlns:a14="http://schemas.microsoft.com/office/drawing/2010/main">
+        <mc:Choice Requires="a14">
+          <p:sp>
+            <p:nvSpPr>
+              <p:cNvPr id="5" name="Content Placeholder 2"/>
+              <p:cNvSpPr>
+                <a:spLocks noGrp="1"/>
+              </p:cNvSpPr>
+              <p:nvPr>
+                <p:ph idx="1"/>
+              </p:nvPr>
+            </p:nvSpPr>
+            <p:spPr>
+              <a:xfrm>
+                <a:off x="838200" y="2696899"/>
+                <a:ext cx="10515600" cy="757777"/>
+              </a:xfrm>
+            </p:spPr>
+            <p:txBody>
+              <a:bodyPr>
+                <a:normAutofit/>
+              </a:bodyPr>
+              <a:lstStyle/>
+              <a:p>
+                <a:pPr marL="0" indent="0">
+                  <a:buNone/>
+                </a:pPr>
+                <a14:m>
+                  <m:oMathPara xmlns:m="http://schemas.openxmlformats.org/officeDocument/2006/math">
+                    <m:oMathParaPr>
+                      <m:jc m:val="centerGroup"/>
+                    </m:oMathParaPr>
+                    <m:oMath xmlns:m="http://schemas.openxmlformats.org/officeDocument/2006/math">
+                      <m:r>
+                        <a:rPr lang="ru-RU" sz="4400" b="0" i="1" smtClean="0">
+                          <a:latin typeface="Cambria Math" panose="02040503050406030204" pitchFamily="18" charset="0"/>
+                        </a:rPr>
+                        <m:t>𝐿𝐺𝐷</m:t>
+                      </m:r>
+                      <m:r>
+                        <a:rPr lang="ru-RU" sz="4400" b="0" i="1" smtClean="0">
+                          <a:latin typeface="Cambria Math" panose="02040503050406030204" pitchFamily="18" charset="0"/>
+                        </a:rPr>
+                        <m:t> = 1 −</m:t>
+                      </m:r>
+                      <m:r>
+                        <a:rPr lang="en-US" sz="4400" b="0" i="1" smtClean="0">
+                          <a:latin typeface="Cambria Math" panose="02040503050406030204" pitchFamily="18" charset="0"/>
+                        </a:rPr>
+                        <m:t>𝑅𝑒𝑐𝑜𝑣𝑒𝑟𝑦</m:t>
+                      </m:r>
+                      <m:r>
+                        <a:rPr lang="en-US" sz="4400" b="0" i="1" smtClean="0">
+                          <a:latin typeface="Cambria Math" panose="02040503050406030204" pitchFamily="18" charset="0"/>
+                        </a:rPr>
+                        <m:t> </m:t>
+                      </m:r>
+                      <m:r>
+                        <a:rPr lang="en-US" sz="4400" b="0" i="1" smtClean="0">
+                          <a:latin typeface="Cambria Math" panose="02040503050406030204" pitchFamily="18" charset="0"/>
+                        </a:rPr>
+                        <m:t>𝑅𝑎𝑡𝑒</m:t>
+                      </m:r>
+                    </m:oMath>
+                  </m:oMathPara>
+                </a14:m>
+                <a:endParaRPr lang="ru-RU" sz="4400" dirty="0"/>
+              </a:p>
+            </p:txBody>
+          </p:sp>
+        </mc:Choice>
+        <mc:Fallback xmlns="">
+          <p:sp>
+            <p:nvSpPr>
+              <p:cNvPr id="5" name="Content Placeholder 2"/>
+              <p:cNvSpPr>
+                <a:spLocks noGrp="1" noRot="1" noChangeAspect="1" noMove="1" noResize="1" noEditPoints="1" noAdjustHandles="1" noChangeArrowheads="1" noChangeShapeType="1" noTextEdit="1"/>
+              </p:cNvSpPr>
+              <p:nvPr>
+                <p:ph idx="1"/>
+              </p:nvPr>
+            </p:nvSpPr>
+            <p:spPr>
+              <a:xfrm>
+                <a:off x="838200" y="2696899"/>
+                <a:ext cx="10515600" cy="757777"/>
+              </a:xfrm>
+              <a:blipFill>
+                <a:blip r:embed="rId2"/>
+                <a:stretch>
+                  <a:fillRect/>
+                </a:stretch>
+              </a:blipFill>
+            </p:spPr>
+            <p:txBody>
+              <a:bodyPr/>
+              <a:lstStyle/>
+              <a:p>
+                <a:r>
+                  <a:rPr lang="ru-RU">
+                    <a:noFill/>
+                  </a:rPr>
+                  <a:t> </a:t>
+                </a:r>
+              </a:p>
+            </p:txBody>
+          </p:sp>
+        </mc:Fallback>
+      </mc:AlternateContent>
+      <p:sp>
+        <p:nvSpPr>
+          <p:cNvPr id="2" name="Rectangle 1"/>
+          <p:cNvSpPr/>
+          <p:nvPr/>
+        </p:nvSpPr>
+        <p:spPr>
+          <a:xfrm>
+            <a:off x="838200" y="4174124"/>
+            <a:ext cx="10804561" cy="523220"/>
+          </a:xfrm>
+          <a:prstGeom prst="rect">
+            <a:avLst/>
+          </a:prstGeom>
+        </p:spPr>
+        <p:txBody>
+          <a:bodyPr wrap="none">
+            <a:spAutoFit/>
+          </a:bodyPr>
+          <a:lstStyle/>
+          <a:p>
+            <a:r>
+              <a:rPr lang="en-US" sz="2800" dirty="0">
+                <a:latin typeface="Sylfaen" panose="010A0502050306030303" pitchFamily="18" charset="0"/>
+                <a:ea typeface="Calibri" panose="020F0502020204030204" pitchFamily="34" charset="0"/>
+                <a:cs typeface="Times New Roman" panose="02020603050405020304" pitchFamily="18" charset="0"/>
+              </a:rPr>
+              <a:t>Recovery </a:t>
+            </a:r>
+            <a:r>
+              <a:rPr lang="en-US" sz="2800" dirty="0" smtClean="0">
+                <a:latin typeface="Sylfaen" panose="010A0502050306030303" pitchFamily="18" charset="0"/>
+                <a:ea typeface="Calibri" panose="020F0502020204030204" pitchFamily="34" charset="0"/>
+                <a:cs typeface="Times New Roman" panose="02020603050405020304" pitchFamily="18" charset="0"/>
+              </a:rPr>
+              <a:t>Rate –</a:t>
+            </a:r>
+            <a:r>
+              <a:rPr lang="hy-AM" sz="2800" dirty="0" smtClean="0">
+                <a:latin typeface="Sylfaen" panose="010A0502050306030303" pitchFamily="18" charset="0"/>
+                <a:ea typeface="Calibri" panose="020F0502020204030204" pitchFamily="34" charset="0"/>
+                <a:cs typeface="Times New Roman" panose="02020603050405020304" pitchFamily="18" charset="0"/>
+              </a:rPr>
+              <a:t>վերականգնվող գումարի տոկոսը դեֆոլտից հետո</a:t>
+            </a:r>
+            <a:endParaRPr lang="ru-RU" sz="2800" dirty="0"/>
+          </a:p>
+        </p:txBody>
+      </p:sp>
+    </p:spTree>
+    <p:extLst>
+      <p:ext uri="{BB962C8B-B14F-4D97-AF65-F5344CB8AC3E}">
+        <p14:creationId xmlns:p14="http://schemas.microsoft.com/office/powerpoint/2010/main" val="639266211"/>
+      </p:ext>
+    </p:extLst>
+  </p:cSld>
+  <p:clrMapOvr>
+    <a:masterClrMapping/>
+  </p:clrMapOvr>
+  <p:timing>
+    <p:tnLst>
+      <p:par>
+        <p:cTn id="1" dur="indefinite" restart="never" nodeType="tmRoot"/>
+      </p:par>
+    </p:tnLst>
+  </p:timing>
+</p:sld>
+</file>
+
+<file path=ppt/slides/slide13.xml><?xml version="1.0" encoding="utf-8"?>
+<p:sld xmlns:a="http://schemas.openxmlformats.org/drawingml/2006/main" xmlns:r="http://schemas.openxmlformats.org/officeDocument/2006/relationships" xmlns:p="http://schemas.openxmlformats.org/presentationml/2006/main">
+  <p:cSld>
+    <p:spTree>
+      <p:nvGrpSpPr>
+        <p:cNvPr id="1" name=""/>
+        <p:cNvGrpSpPr/>
+        <p:nvPr/>
+      </p:nvGrpSpPr>
+      <p:grpSpPr>
+        <a:xfrm>
+          <a:off x="0" y="0"/>
+          <a:ext cx="0" cy="0"/>
+          <a:chOff x="0" y="0"/>
+          <a:chExt cx="0" cy="0"/>
+        </a:xfrm>
+      </p:grpSpPr>
+      <p:sp>
+        <p:nvSpPr>
+          <p:cNvPr id="2" name="Title 1"/>
+          <p:cNvSpPr>
+            <a:spLocks noGrp="1"/>
+          </p:cNvSpPr>
+          <p:nvPr>
+            <p:ph type="title"/>
+          </p:nvPr>
+        </p:nvSpPr>
+        <p:spPr>
+          <a:xfrm>
+            <a:off x="485683" y="924419"/>
+            <a:ext cx="11238390" cy="1325563"/>
+          </a:xfrm>
+        </p:spPr>
+        <p:txBody>
+          <a:bodyPr/>
+          <a:lstStyle/>
+          <a:p>
+            <a:pPr algn="ctr"/>
+            <a:r>
+              <a:rPr lang="en-US" dirty="0" smtClean="0"/>
+              <a:t>ECL (Expected Credit Loss) </a:t>
+            </a:r>
+            <a:r>
+              <a:rPr lang="hy-AM" dirty="0" smtClean="0"/>
+              <a:t>Հաշվման Բանաձևը</a:t>
+            </a:r>
+            <a:endParaRPr lang="ru-RU" dirty="0"/>
+          </a:p>
+        </p:txBody>
+      </p:sp>
+      <mc:AlternateContent xmlns:mc="http://schemas.openxmlformats.org/markup-compatibility/2006" xmlns:a14="http://schemas.microsoft.com/office/drawing/2010/main">
+        <mc:Choice Requires="a14">
+          <p:sp>
+            <p:nvSpPr>
+              <p:cNvPr id="3" name="Content Placeholder 2"/>
+              <p:cNvSpPr>
+                <a:spLocks noGrp="1"/>
+              </p:cNvSpPr>
+              <p:nvPr>
+                <p:ph idx="1"/>
+              </p:nvPr>
+            </p:nvSpPr>
+            <p:spPr>
+              <a:xfrm>
+                <a:off x="1956787" y="3423606"/>
+                <a:ext cx="8030592" cy="784410"/>
+              </a:xfrm>
+            </p:spPr>
+            <p:txBody>
+              <a:bodyPr>
+                <a:normAutofit fontScale="92500"/>
+              </a:bodyPr>
+              <a:lstStyle/>
+              <a:p>
+                <a:pPr marL="0" indent="0">
+                  <a:buNone/>
+                </a:pPr>
+                <a14:m>
+                  <m:oMathPara xmlns:m="http://schemas.openxmlformats.org/officeDocument/2006/math">
+                    <m:oMathParaPr>
+                      <m:jc m:val="centerGroup"/>
+                    </m:oMathParaPr>
+                    <m:oMath xmlns:m="http://schemas.openxmlformats.org/officeDocument/2006/math">
+                      <m:r>
+                        <a:rPr lang="ru-RU" sz="5400" i="1">
+                          <a:latin typeface="Cambria Math" panose="02040503050406030204" pitchFamily="18" charset="0"/>
+                        </a:rPr>
+                        <m:t>𝐸𝐶𝐿</m:t>
+                      </m:r>
+                      <m:r>
+                        <a:rPr lang="ru-RU" sz="5400" i="1">
+                          <a:latin typeface="Cambria Math" panose="02040503050406030204" pitchFamily="18" charset="0"/>
+                        </a:rPr>
+                        <m:t>=</m:t>
+                      </m:r>
+                      <m:r>
+                        <a:rPr lang="ru-RU" sz="5400" i="1">
+                          <a:latin typeface="Cambria Math" panose="02040503050406030204" pitchFamily="18" charset="0"/>
+                        </a:rPr>
+                        <m:t>𝑃𝐷</m:t>
+                      </m:r>
+                      <m:r>
+                        <a:rPr lang="ru-RU" sz="5400" i="1">
+                          <a:latin typeface="Cambria Math" panose="02040503050406030204" pitchFamily="18" charset="0"/>
+                        </a:rPr>
+                        <m:t>×</m:t>
+                      </m:r>
+                      <m:r>
+                        <a:rPr lang="ru-RU" sz="5400" i="1">
+                          <a:latin typeface="Cambria Math" panose="02040503050406030204" pitchFamily="18" charset="0"/>
+                        </a:rPr>
+                        <m:t>𝐸𝐴𝐷</m:t>
+                      </m:r>
+                      <m:r>
+                        <a:rPr lang="ru-RU" sz="5400" i="1">
+                          <a:latin typeface="Cambria Math" panose="02040503050406030204" pitchFamily="18" charset="0"/>
+                        </a:rPr>
+                        <m:t>×</m:t>
+                      </m:r>
+                      <m:r>
+                        <a:rPr lang="ru-RU" sz="5400" i="1">
+                          <a:latin typeface="Cambria Math" panose="02040503050406030204" pitchFamily="18" charset="0"/>
+                        </a:rPr>
+                        <m:t>𝐿𝐺𝐷</m:t>
+                      </m:r>
+                    </m:oMath>
+                  </m:oMathPara>
+                </a14:m>
+                <a:endParaRPr lang="ru-RU" sz="5400" dirty="0"/>
+              </a:p>
+              <a:p>
+                <a:pPr marL="0" indent="0">
+                  <a:buNone/>
+                </a:pPr>
+                <a:endParaRPr lang="ru-RU" sz="5400" dirty="0"/>
+              </a:p>
+            </p:txBody>
+          </p:sp>
+        </mc:Choice>
+        <mc:Fallback xmlns="">
+          <p:sp>
+            <p:nvSpPr>
+              <p:cNvPr id="3" name="Content Placeholder 2"/>
+              <p:cNvSpPr>
+                <a:spLocks noGrp="1" noRot="1" noChangeAspect="1" noMove="1" noResize="1" noEditPoints="1" noAdjustHandles="1" noChangeArrowheads="1" noChangeShapeType="1" noTextEdit="1"/>
+              </p:cNvSpPr>
+              <p:nvPr>
+                <p:ph idx="1"/>
+              </p:nvPr>
+            </p:nvSpPr>
+            <p:spPr>
+              <a:xfrm>
+                <a:off x="1956787" y="3423606"/>
+                <a:ext cx="8030592" cy="784410"/>
+              </a:xfrm>
+              <a:blipFill>
+                <a:blip r:embed="rId2"/>
+                <a:stretch>
+                  <a:fillRect/>
+                </a:stretch>
+              </a:blipFill>
+            </p:spPr>
+            <p:txBody>
+              <a:bodyPr/>
+              <a:lstStyle/>
+              <a:p>
+                <a:r>
+                  <a:rPr lang="ru-RU">
+                    <a:noFill/>
+                  </a:rPr>
+                  <a:t> </a:t>
+                </a:r>
+              </a:p>
+            </p:txBody>
+          </p:sp>
+        </mc:Fallback>
+      </mc:AlternateContent>
+    </p:spTree>
+    <p:extLst>
+      <p:ext uri="{BB962C8B-B14F-4D97-AF65-F5344CB8AC3E}">
+        <p14:creationId xmlns:p14="http://schemas.microsoft.com/office/powerpoint/2010/main" val="1447601428"/>
+      </p:ext>
+    </p:extLst>
+  </p:cSld>
+  <p:clrMapOvr>
+    <a:masterClrMapping/>
+  </p:clrMapOvr>
+  <p:timing>
+    <p:tnLst>
+      <p:par>
+        <p:cTn id="1" dur="indefinite" restart="never" nodeType="tmRoot"/>
+      </p:par>
+    </p:tnLst>
+  </p:timing>
+</p:sld>
+</file>
+
+<file path=ppt/slides/slide14.xml><?xml version="1.0" encoding="utf-8"?>
+<p:sld xmlns:a="http://schemas.openxmlformats.org/drawingml/2006/main" xmlns:r="http://schemas.openxmlformats.org/officeDocument/2006/relationships" xmlns:p="http://schemas.openxmlformats.org/presentationml/2006/main">
+  <p:cSld>
+    <p:spTree>
+      <p:nvGrpSpPr>
+        <p:cNvPr id="1" name=""/>
+        <p:cNvGrpSpPr/>
+        <p:nvPr/>
+      </p:nvGrpSpPr>
+      <p:grpSpPr>
+        <a:xfrm>
+          <a:off x="0" y="0"/>
+          <a:ext cx="0" cy="0"/>
+          <a:chOff x="0" y="0"/>
+          <a:chExt cx="0" cy="0"/>
+        </a:xfrm>
+      </p:grpSpPr>
+      <p:sp>
+        <p:nvSpPr>
+          <p:cNvPr id="2" name="Title 1"/>
+          <p:cNvSpPr>
+            <a:spLocks noGrp="1"/>
+          </p:cNvSpPr>
+          <p:nvPr>
+            <p:ph type="title"/>
+          </p:nvPr>
+        </p:nvSpPr>
+        <p:spPr>
+          <a:xfrm>
+            <a:off x="795512" y="0"/>
+            <a:ext cx="10515600" cy="1325563"/>
+          </a:xfrm>
+        </p:spPr>
+        <p:txBody>
+          <a:bodyPr/>
+          <a:lstStyle/>
+          <a:p>
+            <a:pPr algn="ctr"/>
+            <a:r>
+              <a:rPr lang="en-US" dirty="0" smtClean="0"/>
+              <a:t>ECL-</a:t>
+            </a:r>
+            <a:r>
+              <a:rPr lang="hy-AM" dirty="0" smtClean="0"/>
+              <a:t>ի Հաշվարկման Ալգորիթմը</a:t>
+            </a:r>
+            <a:endParaRPr lang="ru-RU" dirty="0"/>
+          </a:p>
+        </p:txBody>
+      </p:sp>
+      <p:pic>
+        <p:nvPicPr>
+          <p:cNvPr id="4" name="Picture 3"/>
+          <p:cNvPicPr/>
+          <p:nvPr/>
+        </p:nvPicPr>
+        <p:blipFill>
+          <a:blip r:embed="rId2"/>
+          <a:stretch>
+            <a:fillRect/>
+          </a:stretch>
+        </p:blipFill>
+        <p:spPr>
+          <a:xfrm>
+            <a:off x="1917056" y="1322787"/>
+            <a:ext cx="4136256" cy="5060466"/>
+          </a:xfrm>
+          <a:prstGeom prst="rect">
+            <a:avLst/>
+          </a:prstGeom>
+        </p:spPr>
+      </p:pic>
+      <p:pic>
+        <p:nvPicPr>
+          <p:cNvPr id="5" name="Picture 4"/>
+          <p:cNvPicPr/>
+          <p:nvPr/>
+        </p:nvPicPr>
+        <p:blipFill>
+          <a:blip r:embed="rId3"/>
+          <a:stretch>
+            <a:fillRect/>
+          </a:stretch>
+        </p:blipFill>
+        <p:spPr>
+          <a:xfrm>
+            <a:off x="7083214" y="1478630"/>
+            <a:ext cx="2301418" cy="4748780"/>
+          </a:xfrm>
+          <a:prstGeom prst="rect">
+            <a:avLst/>
+          </a:prstGeom>
+        </p:spPr>
+      </p:pic>
+    </p:spTree>
+    <p:extLst>
+      <p:ext uri="{BB962C8B-B14F-4D97-AF65-F5344CB8AC3E}">
+        <p14:creationId xmlns:p14="http://schemas.microsoft.com/office/powerpoint/2010/main" val="2822845314"/>
+      </p:ext>
+    </p:extLst>
+  </p:cSld>
+  <p:clrMapOvr>
+    <a:masterClrMapping/>
+  </p:clrMapOvr>
+  <p:timing>
+    <p:tnLst>
+      <p:par>
+        <p:cTn id="1" dur="indefinite" restart="never" nodeType="tmRoot"/>
+      </p:par>
+    </p:tnLst>
+  </p:timing>
+</p:sld>
+</file>
+
+<file path=ppt/slides/slide15.xml><?xml version="1.0" encoding="utf-8"?>
+<p:sld xmlns:a="http://schemas.openxmlformats.org/drawingml/2006/main" xmlns:r="http://schemas.openxmlformats.org/officeDocument/2006/relationships" xmlns:p="http://schemas.openxmlformats.org/presentationml/2006/main">
+  <p:cSld>
+    <p:spTree>
+      <p:nvGrpSpPr>
+        <p:cNvPr id="1" name=""/>
+        <p:cNvGrpSpPr/>
+        <p:nvPr/>
+      </p:nvGrpSpPr>
+      <p:grpSpPr>
+        <a:xfrm>
+          <a:off x="0" y="0"/>
+          <a:ext cx="0" cy="0"/>
+          <a:chOff x="0" y="0"/>
+          <a:chExt cx="0" cy="0"/>
+        </a:xfrm>
+      </p:grpSpPr>
+      <p:sp>
+        <p:nvSpPr>
+          <p:cNvPr id="5" name="TextBox 4"/>
+          <p:cNvSpPr txBox="1"/>
+          <p:nvPr/>
+        </p:nvSpPr>
+        <p:spPr>
+          <a:xfrm>
+            <a:off x="683623" y="1758672"/>
+            <a:ext cx="4363453" cy="1200329"/>
+          </a:xfrm>
+          <a:prstGeom prst="rect">
+            <a:avLst/>
+          </a:prstGeom>
+          <a:noFill/>
+        </p:spPr>
+        <p:txBody>
+          <a:bodyPr wrap="square" rtlCol="0">
+            <a:spAutoFit/>
+          </a:bodyPr>
+          <a:lstStyle/>
+          <a:p>
+            <a:pPr algn="ctr"/>
+            <a:r>
+              <a:rPr lang="en-US" sz="3600" dirty="0" smtClean="0"/>
+              <a:t>SSMS </a:t>
+            </a:r>
+            <a:r>
+              <a:rPr lang="hy-AM" sz="3600" dirty="0" smtClean="0"/>
+              <a:t>Ծրագրային Միջավայրը</a:t>
+            </a:r>
+            <a:endParaRPr lang="ru-RU" sz="3600" dirty="0"/>
+          </a:p>
+        </p:txBody>
+      </p:sp>
+      <p:pic>
+        <p:nvPicPr>
+          <p:cNvPr id="6" name="Picture 5"/>
+          <p:cNvPicPr>
+            <a:picLocks noChangeAspect="1"/>
+          </p:cNvPicPr>
+          <p:nvPr/>
+        </p:nvPicPr>
+        <p:blipFill>
+          <a:blip r:embed="rId2"/>
+          <a:stretch>
+            <a:fillRect/>
+          </a:stretch>
+        </p:blipFill>
+        <p:spPr>
+          <a:xfrm>
+            <a:off x="5911341" y="0"/>
+            <a:ext cx="6280659" cy="6859834"/>
+          </a:xfrm>
+          <a:prstGeom prst="rect">
+            <a:avLst/>
+          </a:prstGeom>
+        </p:spPr>
+      </p:pic>
+    </p:spTree>
+    <p:extLst>
+      <p:ext uri="{BB962C8B-B14F-4D97-AF65-F5344CB8AC3E}">
+        <p14:creationId xmlns:p14="http://schemas.microsoft.com/office/powerpoint/2010/main" val="700006558"/>
+      </p:ext>
+    </p:extLst>
+  </p:cSld>
+  <p:clrMapOvr>
+    <a:masterClrMapping/>
+  </p:clrMapOvr>
+</p:sld>
+</file>
+
+<file path=ppt/slides/slide16.xml><?xml version="1.0" encoding="utf-8"?>
+<p:sld xmlns:a="http://schemas.openxmlformats.org/drawingml/2006/main" xmlns:r="http://schemas.openxmlformats.org/officeDocument/2006/relationships" xmlns:p="http://schemas.openxmlformats.org/presentationml/2006/main">
+  <p:cSld>
+    <p:spTree>
+      <p:nvGrpSpPr>
+        <p:cNvPr id="1" name=""/>
+        <p:cNvGrpSpPr/>
+        <p:nvPr/>
+      </p:nvGrpSpPr>
+      <p:grpSpPr>
+        <a:xfrm>
+          <a:off x="0" y="0"/>
+          <a:ext cx="0" cy="0"/>
+          <a:chOff x="0" y="0"/>
+          <a:chExt cx="0" cy="0"/>
+        </a:xfrm>
+      </p:grpSpPr>
+      <p:pic>
+        <p:nvPicPr>
+          <p:cNvPr id="5" name="Picture 4"/>
+          <p:cNvPicPr>
+            <a:picLocks noChangeAspect="1"/>
+          </p:cNvPicPr>
+          <p:nvPr/>
+        </p:nvPicPr>
+        <p:blipFill>
+          <a:blip r:embed="rId2">
+            <a:extLst>
+              <a:ext uri="{28A0092B-C50C-407E-A947-70E740481C1C}">
+                <a14:useLocalDpi xmlns:a14="http://schemas.microsoft.com/office/drawing/2010/main" val="0"/>
+              </a:ext>
+            </a:extLst>
+          </a:blip>
+          <a:stretch>
+            <a:fillRect/>
+          </a:stretch>
+        </p:blipFill>
+        <p:spPr>
+          <a:xfrm>
+            <a:off x="385009" y="0"/>
+            <a:ext cx="11505039" cy="6858000"/>
+          </a:xfrm>
+          <a:prstGeom prst="rect">
+            <a:avLst/>
+          </a:prstGeom>
+        </p:spPr>
+      </p:pic>
+    </p:spTree>
+    <p:extLst>
+      <p:ext uri="{BB962C8B-B14F-4D97-AF65-F5344CB8AC3E}">
+        <p14:creationId xmlns:p14="http://schemas.microsoft.com/office/powerpoint/2010/main" val="1405011281"/>
+      </p:ext>
+    </p:extLst>
+  </p:cSld>
+  <p:clrMapOvr>
+    <a:masterClrMapping/>
+  </p:clrMapOvr>
+</p:sld>
+</file>
+
+<file path=ppt/slides/slide17.xml><?xml version="1.0" encoding="utf-8"?>
+<p:sld xmlns:a="http://schemas.openxmlformats.org/drawingml/2006/main" xmlns:r="http://schemas.openxmlformats.org/officeDocument/2006/relationships" xmlns:p="http://schemas.openxmlformats.org/presentationml/2006/main">
+  <p:cSld>
+    <p:spTree>
+      <p:nvGrpSpPr>
+        <p:cNvPr id="1" name=""/>
+        <p:cNvGrpSpPr/>
+        <p:nvPr/>
+      </p:nvGrpSpPr>
+      <p:grpSpPr>
+        <a:xfrm>
+          <a:off x="0" y="0"/>
+          <a:ext cx="0" cy="0"/>
+          <a:chOff x="0" y="0"/>
+          <a:chExt cx="0" cy="0"/>
+        </a:xfrm>
+      </p:grpSpPr>
+      <p:pic>
+        <p:nvPicPr>
+          <p:cNvPr id="4" name="Picture 3"/>
+          <p:cNvPicPr>
+            <a:picLocks noChangeAspect="1"/>
+          </p:cNvPicPr>
+          <p:nvPr/>
+        </p:nvPicPr>
+        <p:blipFill>
+          <a:blip r:embed="rId2">
+            <a:extLst>
+              <a:ext uri="{28A0092B-C50C-407E-A947-70E740481C1C}">
+                <a14:useLocalDpi xmlns:a14="http://schemas.microsoft.com/office/drawing/2010/main" val="0"/>
+              </a:ext>
+            </a:extLst>
+          </a:blip>
+          <a:stretch>
+            <a:fillRect/>
+          </a:stretch>
+        </p:blipFill>
+        <p:spPr>
+          <a:xfrm>
+            <a:off x="112295" y="0"/>
+            <a:ext cx="11897304" cy="6858000"/>
+          </a:xfrm>
+          <a:prstGeom prst="rect">
+            <a:avLst/>
+          </a:prstGeom>
+        </p:spPr>
+      </p:pic>
+    </p:spTree>
+    <p:extLst>
+      <p:ext uri="{BB962C8B-B14F-4D97-AF65-F5344CB8AC3E}">
+        <p14:creationId xmlns:p14="http://schemas.microsoft.com/office/powerpoint/2010/main" val="3858784998"/>
+      </p:ext>
+    </p:extLst>
+  </p:cSld>
+  <p:clrMapOvr>
+    <a:masterClrMapping/>
+  </p:clrMapOvr>
+</p:sld>
+</file>
+
+<file path=ppt/slides/slide2.xml><?xml version="1.0" encoding="utf-8"?>
+<p:sld xmlns:a="http://schemas.openxmlformats.org/drawingml/2006/main" xmlns:r="http://schemas.openxmlformats.org/officeDocument/2006/relationships" xmlns:p="http://schemas.openxmlformats.org/presentationml/2006/main">
+  <p:cSld>
+    <p:spTree>
+      <p:nvGrpSpPr>
+        <p:cNvPr id="1" name=""/>
+        <p:cNvGrpSpPr/>
+        <p:nvPr/>
+      </p:nvGrpSpPr>
+      <p:grpSpPr>
+        <a:xfrm>
+          <a:off x="0" y="0"/>
+          <a:ext cx="0" cy="0"/>
+          <a:chOff x="0" y="0"/>
+          <a:chExt cx="0" cy="0"/>
+        </a:xfrm>
+      </p:grpSpPr>
+      <p:sp>
+        <p:nvSpPr>
+          <p:cNvPr id="2" name="Title 1"/>
+          <p:cNvSpPr>
+            <a:spLocks noGrp="1"/>
+          </p:cNvSpPr>
+          <p:nvPr>
+            <p:ph type="title"/>
+          </p:nvPr>
+        </p:nvSpPr>
+        <p:spPr/>
+        <p:txBody>
+          <a:bodyPr/>
+          <a:lstStyle/>
+          <a:p>
+            <a:pPr algn="ctr"/>
+            <a:r>
+              <a:rPr lang="hy-AM" dirty="0" smtClean="0">
+                <a:latin typeface="Stylafen"/>
+              </a:rPr>
+              <a:t>Ամպային Տեխնոլոգիաներ</a:t>
+            </a:r>
+            <a:endParaRPr lang="ru-RU" dirty="0">
+              <a:latin typeface="Stylafen"/>
+            </a:endParaRPr>
+          </a:p>
+        </p:txBody>
+      </p:sp>
+      <p:pic>
+        <p:nvPicPr>
+          <p:cNvPr id="7" name="Content Placeholder 6"/>
+          <p:cNvPicPr>
+            <a:picLocks noGrp="1" noChangeAspect="1"/>
+          </p:cNvPicPr>
+          <p:nvPr>
+            <p:ph idx="1"/>
+          </p:nvPr>
+        </p:nvPicPr>
+        <p:blipFill>
+          <a:blip r:embed="rId2" cstate="print">
+            <a:extLst>
+              <a:ext uri="{28A0092B-C50C-407E-A947-70E740481C1C}">
+                <a14:useLocalDpi xmlns:a14="http://schemas.microsoft.com/office/drawing/2010/main" val="0"/>
+              </a:ext>
+            </a:extLst>
+          </a:blip>
+          <a:stretch>
+            <a:fillRect/>
+          </a:stretch>
+        </p:blipFill>
+        <p:spPr>
+          <a:xfrm>
+            <a:off x="838200" y="2082389"/>
+            <a:ext cx="10515600" cy="3837810"/>
+          </a:xfrm>
+        </p:spPr>
+      </p:pic>
+    </p:spTree>
+    <p:extLst>
+      <p:ext uri="{BB962C8B-B14F-4D97-AF65-F5344CB8AC3E}">
+        <p14:creationId xmlns:p14="http://schemas.microsoft.com/office/powerpoint/2010/main" val="295587833"/>
+      </p:ext>
+    </p:extLst>
+  </p:cSld>
+  <p:clrMapOvr>
+    <a:masterClrMapping/>
+  </p:clrMapOvr>
+  <p:timing>
+    <p:tnLst>
+      <p:par>
+        <p:cTn id="1" dur="indefinite" restart="never" nodeType="tmRoot"/>
+      </p:par>
+    </p:tnLst>
+  </p:timing>
+</p:sld>
+</file>
+
+<file path=ppt/slides/slide3.xml><?xml version="1.0" encoding="utf-8"?>
+<p:sld xmlns:a="http://schemas.openxmlformats.org/drawingml/2006/main" xmlns:r="http://schemas.openxmlformats.org/officeDocument/2006/relationships" xmlns:p="http://schemas.openxmlformats.org/presentationml/2006/main">
+  <p:cSld>
+    <p:spTree>
+      <p:nvGrpSpPr>
+        <p:cNvPr id="1" name=""/>
+        <p:cNvGrpSpPr/>
+        <p:nvPr/>
+      </p:nvGrpSpPr>
+      <p:grpSpPr>
+        <a:xfrm>
+          <a:off x="0" y="0"/>
+          <a:ext cx="0" cy="0"/>
+          <a:chOff x="0" y="0"/>
+          <a:chExt cx="0" cy="0"/>
+        </a:xfrm>
+      </p:grpSpPr>
+      <p:pic>
+        <p:nvPicPr>
+          <p:cNvPr id="6" name="Picture 5"/>
+          <p:cNvPicPr>
+            <a:picLocks noChangeAspect="1"/>
+          </p:cNvPicPr>
+          <p:nvPr/>
+        </p:nvPicPr>
+        <p:blipFill>
+          <a:blip r:embed="rId2">
+            <a:extLst>
+              <a:ext uri="{28A0092B-C50C-407E-A947-70E740481C1C}">
+                <a14:useLocalDpi xmlns:a14="http://schemas.microsoft.com/office/drawing/2010/main" val="0"/>
+              </a:ext>
+            </a:extLst>
+          </a:blip>
+          <a:stretch>
+            <a:fillRect/>
+          </a:stretch>
+        </p:blipFill>
+        <p:spPr>
+          <a:xfrm>
+            <a:off x="-1" y="-1"/>
+            <a:ext cx="6862439" cy="6862439"/>
+          </a:xfrm>
+          <a:prstGeom prst="rect">
+            <a:avLst/>
+          </a:prstGeom>
+        </p:spPr>
+      </p:pic>
+      <p:sp>
+        <p:nvSpPr>
+          <p:cNvPr id="7" name="TextBox 6"/>
+          <p:cNvSpPr txBox="1"/>
+          <p:nvPr/>
+        </p:nvSpPr>
+        <p:spPr>
+          <a:xfrm>
+            <a:off x="8047608" y="3346882"/>
+            <a:ext cx="3129377" cy="400110"/>
+          </a:xfrm>
+          <a:prstGeom prst="rect">
+            <a:avLst/>
+          </a:prstGeom>
+          <a:noFill/>
+        </p:spPr>
+        <p:txBody>
+          <a:bodyPr wrap="square" rtlCol="0">
+            <a:spAutoFit/>
+          </a:bodyPr>
+          <a:lstStyle/>
+          <a:p>
+            <a:r>
+              <a:rPr lang="en-US" sz="2000" dirty="0"/>
+              <a:t>https://</a:t>
+            </a:r>
+            <a:r>
+              <a:rPr lang="en-US" sz="2000" dirty="0" smtClean="0"/>
+              <a:t>www.statista.com</a:t>
+            </a:r>
+            <a:endParaRPr lang="ru-RU" sz="2000" dirty="0"/>
+          </a:p>
+        </p:txBody>
+      </p:sp>
+    </p:spTree>
+    <p:extLst>
+      <p:ext uri="{BB962C8B-B14F-4D97-AF65-F5344CB8AC3E}">
+        <p14:creationId xmlns:p14="http://schemas.microsoft.com/office/powerpoint/2010/main" val="1416974609"/>
+      </p:ext>
+    </p:extLst>
+  </p:cSld>
+  <p:clrMapOvr>
+    <a:masterClrMapping/>
+  </p:clrMapOvr>
+  <p:timing>
+    <p:tnLst>
+      <p:par>
+        <p:cTn id="1" dur="indefinite" restart="never" nodeType="tmRoot"/>
+      </p:par>
+    </p:tnLst>
+  </p:timing>
+</p:sld>
+</file>
+
+<file path=ppt/slides/slide4.xml><?xml version="1.0" encoding="utf-8"?>
+<p:sld xmlns:a="http://schemas.openxmlformats.org/drawingml/2006/main" xmlns:r="http://schemas.openxmlformats.org/officeDocument/2006/relationships" xmlns:p="http://schemas.openxmlformats.org/presentationml/2006/main">
+  <p:cSld>
+    <p:spTree>
+      <p:nvGrpSpPr>
+        <p:cNvPr id="1" name=""/>
+        <p:cNvGrpSpPr/>
+        <p:nvPr/>
+      </p:nvGrpSpPr>
+      <p:grpSpPr>
+        <a:xfrm>
+          <a:off x="0" y="0"/>
+          <a:ext cx="0" cy="0"/>
+          <a:chOff x="0" y="0"/>
+          <a:chExt cx="0" cy="0"/>
+        </a:xfrm>
+      </p:grpSpPr>
+      <p:sp>
+        <p:nvSpPr>
+          <p:cNvPr id="5" name="TextBox 4"/>
+          <p:cNvSpPr txBox="1"/>
+          <p:nvPr/>
+        </p:nvSpPr>
+        <p:spPr>
+          <a:xfrm>
+            <a:off x="417250" y="337351"/>
+            <a:ext cx="11390051" cy="769441"/>
+          </a:xfrm>
+          <a:prstGeom prst="rect">
+            <a:avLst/>
+          </a:prstGeom>
+          <a:noFill/>
+        </p:spPr>
+        <p:txBody>
+          <a:bodyPr wrap="square" rtlCol="0">
+            <a:spAutoFit/>
+          </a:bodyPr>
+          <a:lstStyle/>
+          <a:p>
+            <a:pPr algn="ctr"/>
+            <a:r>
+              <a:rPr lang="en-US" sz="4400" dirty="0" smtClean="0"/>
+              <a:t>ETL </a:t>
+            </a:r>
+            <a:r>
+              <a:rPr lang="hy-AM" sz="4400" dirty="0" smtClean="0"/>
+              <a:t>և </a:t>
+            </a:r>
+            <a:r>
+              <a:rPr lang="en-US" sz="4400" dirty="0" smtClean="0"/>
+              <a:t>ELT</a:t>
+            </a:r>
+            <a:r>
+              <a:rPr lang="hy-AM" sz="4400" dirty="0"/>
+              <a:t> </a:t>
+            </a:r>
+            <a:r>
+              <a:rPr lang="hy-AM" sz="4400" dirty="0" smtClean="0"/>
+              <a:t>տվյալների ինտեգրման եղանակներ</a:t>
+            </a:r>
+            <a:endParaRPr lang="ru-RU" sz="4400" dirty="0"/>
+          </a:p>
+        </p:txBody>
+      </p:sp>
+      <p:pic>
+        <p:nvPicPr>
+          <p:cNvPr id="2" name="Picture 1"/>
+          <p:cNvPicPr>
+            <a:picLocks noChangeAspect="1"/>
+          </p:cNvPicPr>
+          <p:nvPr/>
+        </p:nvPicPr>
+        <p:blipFill>
+          <a:blip r:embed="rId2"/>
+          <a:stretch>
+            <a:fillRect/>
+          </a:stretch>
+        </p:blipFill>
+        <p:spPr>
+          <a:xfrm>
+            <a:off x="1201452" y="1204195"/>
+            <a:ext cx="9821646" cy="4982270"/>
+          </a:xfrm>
+          <a:prstGeom prst="rect">
+            <a:avLst/>
+          </a:prstGeom>
+        </p:spPr>
+      </p:pic>
+    </p:spTree>
+    <p:extLst>
+      <p:ext uri="{BB962C8B-B14F-4D97-AF65-F5344CB8AC3E}">
+        <p14:creationId xmlns:p14="http://schemas.microsoft.com/office/powerpoint/2010/main" val="948259556"/>
+      </p:ext>
+    </p:extLst>
+  </p:cSld>
+  <p:clrMapOvr>
+    <a:masterClrMapping/>
+  </p:clrMapOvr>
+  <p:timing>
+    <p:tnLst>
+      <p:par>
+        <p:cTn id="1" dur="indefinite" restart="never" nodeType="tmRoot"/>
+      </p:par>
+    </p:tnLst>
+  </p:timing>
+</p:sld>
+</file>
+
+<file path=ppt/slides/slide5.xml><?xml version="1.0" encoding="utf-8"?>
+<p:sld xmlns:a="http://schemas.openxmlformats.org/drawingml/2006/main" xmlns:r="http://schemas.openxmlformats.org/officeDocument/2006/relationships" xmlns:p="http://schemas.openxmlformats.org/presentationml/2006/main">
+  <p:cSld>
+    <p:spTree>
+      <p:nvGrpSpPr>
+        <p:cNvPr id="1" name=""/>
+        <p:cNvGrpSpPr/>
+        <p:nvPr/>
+      </p:nvGrpSpPr>
+      <p:grpSpPr>
+        <a:xfrm>
+          <a:off x="0" y="0"/>
+          <a:ext cx="0" cy="0"/>
+          <a:chOff x="0" y="0"/>
+          <a:chExt cx="0" cy="0"/>
+        </a:xfrm>
+      </p:grpSpPr>
+      <p:sp>
+        <p:nvSpPr>
+          <p:cNvPr id="2" name="Title 1"/>
+          <p:cNvSpPr>
+            <a:spLocks noGrp="1"/>
+          </p:cNvSpPr>
+          <p:nvPr>
+            <p:ph type="title"/>
+          </p:nvPr>
+        </p:nvSpPr>
+        <p:spPr>
+          <a:xfrm>
+            <a:off x="1352614" y="365125"/>
+            <a:ext cx="6929761" cy="1325563"/>
+          </a:xfrm>
+        </p:spPr>
+        <p:txBody>
+          <a:bodyPr/>
+          <a:lstStyle/>
+          <a:p>
+            <a:pPr algn="ctr"/>
+            <a:r>
+              <a:rPr lang="en-US" dirty="0" smtClean="0">
+                <a:latin typeface="Stylafen"/>
+              </a:rPr>
+              <a:t>Azure Data Factory (ADF)</a:t>
+            </a:r>
+            <a:endParaRPr lang="ru-RU" dirty="0">
+              <a:latin typeface="Stylafen"/>
+            </a:endParaRPr>
+          </a:p>
+        </p:txBody>
+      </p:sp>
+      <p:pic>
+        <p:nvPicPr>
+          <p:cNvPr id="4" name="Content Placeholder 3"/>
+          <p:cNvPicPr>
+            <a:picLocks noGrp="1" noChangeAspect="1"/>
+          </p:cNvPicPr>
+          <p:nvPr>
+            <p:ph idx="1"/>
+          </p:nvPr>
+        </p:nvPicPr>
+        <p:blipFill>
+          <a:blip r:embed="rId2" cstate="print">
+            <a:extLst>
+              <a:ext uri="{28A0092B-C50C-407E-A947-70E740481C1C}">
+                <a14:useLocalDpi xmlns:a14="http://schemas.microsoft.com/office/drawing/2010/main" val="0"/>
+              </a:ext>
+            </a:extLst>
+          </a:blip>
+          <a:stretch>
+            <a:fillRect/>
+          </a:stretch>
+        </p:blipFill>
+        <p:spPr>
+          <a:xfrm>
+            <a:off x="1352614" y="1905524"/>
+            <a:ext cx="8936358" cy="4351338"/>
+          </a:xfrm>
+        </p:spPr>
+      </p:pic>
+      <p:pic>
+        <p:nvPicPr>
+          <p:cNvPr id="7" name="Picture 6"/>
+          <p:cNvPicPr>
+            <a:picLocks noChangeAspect="1"/>
+          </p:cNvPicPr>
+          <p:nvPr/>
+        </p:nvPicPr>
+        <p:blipFill>
+          <a:blip r:embed="rId3"/>
+          <a:stretch>
+            <a:fillRect/>
+          </a:stretch>
+        </p:blipFill>
+        <p:spPr>
+          <a:xfrm>
+            <a:off x="8522240" y="632804"/>
+            <a:ext cx="905846" cy="905846"/>
+          </a:xfrm>
+          <a:prstGeom prst="rect">
+            <a:avLst/>
+          </a:prstGeom>
+        </p:spPr>
+      </p:pic>
+    </p:spTree>
+    <p:extLst>
+      <p:ext uri="{BB962C8B-B14F-4D97-AF65-F5344CB8AC3E}">
+        <p14:creationId xmlns:p14="http://schemas.microsoft.com/office/powerpoint/2010/main" val="2407570629"/>
+      </p:ext>
+    </p:extLst>
+  </p:cSld>
+  <p:clrMapOvr>
+    <a:masterClrMapping/>
+  </p:clrMapOvr>
+  <p:timing>
+    <p:tnLst>
+      <p:par>
+        <p:cTn id="1" dur="indefinite" restart="never" nodeType="tmRoot"/>
+      </p:par>
+    </p:tnLst>
+  </p:timing>
+</p:sld>
+</file>
+
+<file path=ppt/slides/slide6.xml><?xml version="1.0" encoding="utf-8"?>
+<p:sld xmlns:a="http://schemas.openxmlformats.org/drawingml/2006/main" xmlns:r="http://schemas.openxmlformats.org/officeDocument/2006/relationships" xmlns:p="http://schemas.openxmlformats.org/presentationml/2006/main">
+  <p:cSld>
+    <p:spTree>
+      <p:nvGrpSpPr>
+        <p:cNvPr id="1" name=""/>
+        <p:cNvGrpSpPr/>
+        <p:nvPr/>
+      </p:nvGrpSpPr>
+      <p:grpSpPr>
+        <a:xfrm>
+          <a:off x="0" y="0"/>
+          <a:ext cx="0" cy="0"/>
+          <a:chOff x="0" y="0"/>
+          <a:chExt cx="0" cy="0"/>
+        </a:xfrm>
+      </p:grpSpPr>
       <p:sp>
         <p:nvSpPr>
           <p:cNvPr id="2" name="Title 1"/>
@@ -3287,7 +4875,7 @@
 </p:sld>
 </file>
 
-<file path=ppt/slides/slide11.xml><?xml version="1.0" encoding="utf-8"?>
+<file path=ppt/slides/slide7.xml><?xml version="1.0" encoding="utf-8"?>
 <p:sld xmlns:a="http://schemas.openxmlformats.org/drawingml/2006/main" xmlns:r="http://schemas.openxmlformats.org/officeDocument/2006/relationships" xmlns:p="http://schemas.openxmlformats.org/presentationml/2006/main">
   <p:cSld>
     <p:spTree>
@@ -4044,7 +5632,7 @@
 </p:sld>
 </file>
 
-<file path=ppt/slides/slide12.xml><?xml version="1.0" encoding="utf-8"?>
+<file path=ppt/slides/slide8.xml><?xml version="1.0" encoding="utf-8"?>
 <p:sld xmlns:a="http://schemas.openxmlformats.org/drawingml/2006/main" xmlns:r="http://schemas.openxmlformats.org/officeDocument/2006/relationships" xmlns:p="http://schemas.openxmlformats.org/presentationml/2006/main">
   <p:cSld>
     <p:spTree>
@@ -4122,7 +5710,7 @@
 </p:sld>
 </file>
 
-<file path=ppt/slides/slide13.xml><?xml version="1.0" encoding="utf-8"?>
+<file path=ppt/slides/slide9.xml><?xml version="1.0" encoding="utf-8"?>
 <p:sld xmlns:a="http://schemas.openxmlformats.org/drawingml/2006/main" xmlns:r="http://schemas.openxmlformats.org/officeDocument/2006/relationships" xmlns:p="http://schemas.openxmlformats.org/presentationml/2006/main">
   <p:cSld>
     <p:spTree>
@@ -4139,8 +5727,8 @@
           <a:chExt cx="0" cy="0"/>
         </a:xfrm>
       </p:grpSpPr>
-      <mc:AlternateContent xmlns:mc="http://schemas.openxmlformats.org/markup-compatibility/2006">
-        <mc:Choice xmlns:a14="http://schemas.microsoft.com/office/drawing/2010/main" Requires="a14">
+      <mc:AlternateContent xmlns:mc="http://schemas.openxmlformats.org/markup-compatibility/2006" xmlns:a14="http://schemas.microsoft.com/office/drawing/2010/main">
+        <mc:Choice Requires="a14">
           <p:sp>
             <p:nvSpPr>
               <p:cNvPr id="2" name="Title 1"/>
@@ -4170,15 +5758,15 @@
                         <m:sty m:val="p"/>
                       </m:rPr>
                       <a:rPr lang="en-US" sz="3200" i="0" smtClean="0">
-                        <a:latin typeface="+mn-lt"/>
+                        <a:latin typeface="Cambria Math" panose="02040503050406030204" pitchFamily="18" charset="0"/>
                       </a:rPr>
                       <m:t>tahn</m:t>
                     </m:r>
                     <m:d>
                       <m:dPr>
                         <m:ctrlPr>
-                          <a:rPr lang="ru-RU" sz="3200">
-                            <a:latin typeface="+mn-lt"/>
+                          <a:rPr lang="ru-RU" sz="3200" i="1">
+                            <a:latin typeface="Cambria Math" panose="02040503050406030204" pitchFamily="18" charset="0"/>
                           </a:rPr>
                         </m:ctrlPr>
                       </m:dPr>
@@ -4188,7 +5776,7 @@
                             <m:sty m:val="p"/>
                           </m:rPr>
                           <a:rPr lang="hy-AM" sz="3200" i="0">
-                            <a:latin typeface="+mn-lt"/>
+                            <a:latin typeface="Cambria Math" panose="02040503050406030204" pitchFamily="18" charset="0"/>
                           </a:rPr>
                           <m:t>x</m:t>
                         </m:r>
@@ -4196,15 +5784,15 @@
                     </m:d>
                     <m:r>
                       <a:rPr lang="hy-AM" sz="3200" i="0">
-                        <a:latin typeface="+mn-lt"/>
+                        <a:latin typeface="Cambria Math" panose="02040503050406030204" pitchFamily="18" charset="0"/>
                       </a:rPr>
                       <m:t>=</m:t>
                     </m:r>
                     <m:f>
                       <m:fPr>
                         <m:ctrlPr>
-                          <a:rPr lang="ru-RU" sz="3200">
-                            <a:latin typeface="+mn-lt"/>
+                          <a:rPr lang="ru-RU" sz="3200" i="1">
+                            <a:latin typeface="Cambria Math" panose="02040503050406030204" pitchFamily="18" charset="0"/>
                           </a:rPr>
                         </m:ctrlPr>
                       </m:fPr>
@@ -4212,8 +5800,8 @@
                         <m:sSup>
                           <m:sSupPr>
                             <m:ctrlPr>
-                              <a:rPr lang="ru-RU" sz="3200">
-                                <a:latin typeface="+mn-lt"/>
+                              <a:rPr lang="ru-RU" sz="3200" i="1">
+                                <a:latin typeface="Cambria Math" panose="02040503050406030204" pitchFamily="18" charset="0"/>
                               </a:rPr>
                             </m:ctrlPr>
                           </m:sSupPr>
@@ -4223,7 +5811,7 @@
                                 <m:sty m:val="p"/>
                               </m:rPr>
                               <a:rPr lang="hy-AM" sz="3200" i="0">
-                                <a:latin typeface="+mn-lt"/>
+                                <a:latin typeface="Cambria Math" panose="02040503050406030204" pitchFamily="18" charset="0"/>
                               </a:rPr>
                               <m:t>e</m:t>
                             </m:r>
@@ -4234,7 +5822,7 @@
                                 <m:sty m:val="p"/>
                               </m:rPr>
                               <a:rPr lang="hy-AM" sz="3200" i="0">
-                                <a:latin typeface="+mn-lt"/>
+                                <a:latin typeface="Cambria Math" panose="02040503050406030204" pitchFamily="18" charset="0"/>
                               </a:rPr>
                               <m:t>x</m:t>
                             </m:r>
@@ -4242,15 +5830,15 @@
                         </m:sSup>
                         <m:r>
                           <a:rPr lang="hy-AM" sz="3200" i="0">
-                            <a:latin typeface="+mn-lt"/>
+                            <a:latin typeface="Cambria Math" panose="02040503050406030204" pitchFamily="18" charset="0"/>
                           </a:rPr>
                           <m:t>−</m:t>
                         </m:r>
                         <m:sSup>
                           <m:sSupPr>
                             <m:ctrlPr>
-                              <a:rPr lang="ru-RU" sz="3200">
-                                <a:latin typeface="+mn-lt"/>
+                              <a:rPr lang="ru-RU" sz="3200" i="1">
+                                <a:latin typeface="Cambria Math" panose="02040503050406030204" pitchFamily="18" charset="0"/>
                               </a:rPr>
                             </m:ctrlPr>
                           </m:sSupPr>
@@ -4260,7 +5848,7 @@
                                 <m:sty m:val="p"/>
                               </m:rPr>
                               <a:rPr lang="hy-AM" sz="3200" i="0">
-                                <a:latin typeface="+mn-lt"/>
+                                <a:latin typeface="Cambria Math" panose="02040503050406030204" pitchFamily="18" charset="0"/>
                               </a:rPr>
                               <m:t>e</m:t>
                             </m:r>
@@ -4268,7 +5856,7 @@
                           <m:sup>
                             <m:r>
                               <a:rPr lang="hy-AM" sz="3200" i="0">
-                                <a:latin typeface="+mn-lt"/>
+                                <a:latin typeface="Cambria Math" panose="02040503050406030204" pitchFamily="18" charset="0"/>
                               </a:rPr>
                               <m:t>−</m:t>
                             </m:r>
@@ -4277,7 +5865,7 @@
                                 <m:sty m:val="p"/>
                               </m:rPr>
                               <a:rPr lang="hy-AM" sz="3200" i="0">
-                                <a:latin typeface="+mn-lt"/>
+                                <a:latin typeface="Cambria Math" panose="02040503050406030204" pitchFamily="18" charset="0"/>
                               </a:rPr>
                               <m:t>x</m:t>
                             </m:r>
@@ -4288,8 +5876,8 @@
                         <m:sSup>
                           <m:sSupPr>
                             <m:ctrlPr>
-                              <a:rPr lang="ru-RU" sz="3200">
-                                <a:latin typeface="+mn-lt"/>
+                              <a:rPr lang="ru-RU" sz="3200" i="1">
+                                <a:latin typeface="Cambria Math" panose="02040503050406030204" pitchFamily="18" charset="0"/>
                               </a:rPr>
                             </m:ctrlPr>
                           </m:sSupPr>
@@ -4299,7 +5887,7 @@
                                 <m:sty m:val="p"/>
                               </m:rPr>
                               <a:rPr lang="hy-AM" sz="3200" i="0">
-                                <a:latin typeface="+mn-lt"/>
+                                <a:latin typeface="Cambria Math" panose="02040503050406030204" pitchFamily="18" charset="0"/>
                               </a:rPr>
                               <m:t>e</m:t>
                             </m:r>
@@ -4310,7 +5898,7 @@
                                 <m:sty m:val="p"/>
                               </m:rPr>
                               <a:rPr lang="hy-AM" sz="3200" i="0">
-                                <a:latin typeface="+mn-lt"/>
+                                <a:latin typeface="Cambria Math" panose="02040503050406030204" pitchFamily="18" charset="0"/>
                               </a:rPr>
                               <m:t>x</m:t>
                             </m:r>
@@ -4318,15 +5906,15 @@
                         </m:sSup>
                         <m:r>
                           <a:rPr lang="hy-AM" sz="3200" i="0">
-                            <a:latin typeface="+mn-lt"/>
+                            <a:latin typeface="Cambria Math" panose="02040503050406030204" pitchFamily="18" charset="0"/>
                           </a:rPr>
                           <m:t>+</m:t>
                         </m:r>
                         <m:sSup>
                           <m:sSupPr>
                             <m:ctrlPr>
-                              <a:rPr lang="ru-RU" sz="3200">
-                                <a:latin typeface="+mn-lt"/>
+                              <a:rPr lang="ru-RU" sz="3200" i="1">
+                                <a:latin typeface="Cambria Math" panose="02040503050406030204" pitchFamily="18" charset="0"/>
                               </a:rPr>
                             </m:ctrlPr>
                           </m:sSupPr>
@@ -4336,7 +5924,7 @@
                                 <m:sty m:val="p"/>
                               </m:rPr>
                               <a:rPr lang="hy-AM" sz="3200" i="0">
-                                <a:latin typeface="+mn-lt"/>
+                                <a:latin typeface="Cambria Math" panose="02040503050406030204" pitchFamily="18" charset="0"/>
                               </a:rPr>
                               <m:t>e</m:t>
                             </m:r>
@@ -4344,7 +5932,7 @@
                           <m:sup>
                             <m:r>
                               <a:rPr lang="hy-AM" sz="3200" i="0">
-                                <a:latin typeface="+mn-lt"/>
+                                <a:latin typeface="Cambria Math" panose="02040503050406030204" pitchFamily="18" charset="0"/>
                               </a:rPr>
                               <m:t>−</m:t>
                             </m:r>
@@ -4353,7 +5941,7 @@
                                 <m:sty m:val="p"/>
                               </m:rPr>
                               <a:rPr lang="hy-AM" sz="3200" i="0">
-                                <a:latin typeface="+mn-lt"/>
+                                <a:latin typeface="Cambria Math" panose="02040503050406030204" pitchFamily="18" charset="0"/>
                               </a:rPr>
                               <m:t>x</m:t>
                             </m:r>
@@ -4433,7 +6021,7 @@
             </p:txBody>
           </p:sp>
         </mc:Choice>
-        <mc:Fallback>
+        <mc:Fallback xmlns="">
           <p:sp>
             <p:nvSpPr>
               <p:cNvPr id="2" name="Title 1"/>
@@ -4497,1971 +6085,6 @@
     <p:extLst>
       <p:ext uri="{BB962C8B-B14F-4D97-AF65-F5344CB8AC3E}">
         <p14:creationId xmlns:p14="http://schemas.microsoft.com/office/powerpoint/2010/main" val="1836136403"/>
-      </p:ext>
-    </p:extLst>
-  </p:cSld>
-  <p:clrMapOvr>
-    <a:masterClrMapping/>
-  </p:clrMapOvr>
-  <p:timing>
-    <p:tnLst>
-      <p:par>
-        <p:cTn id="1" dur="indefinite" restart="never" nodeType="tmRoot"/>
-      </p:par>
-    </p:tnLst>
-  </p:timing>
-</p:sld>
-</file>
-
-<file path=ppt/slides/slide14.xml><?xml version="1.0" encoding="utf-8"?>
-<p:sld xmlns:a="http://schemas.openxmlformats.org/drawingml/2006/main" xmlns:r="http://schemas.openxmlformats.org/officeDocument/2006/relationships" xmlns:p="http://schemas.openxmlformats.org/presentationml/2006/main">
-  <p:cSld>
-    <p:spTree>
-      <p:nvGrpSpPr>
-        <p:cNvPr id="1" name=""/>
-        <p:cNvGrpSpPr/>
-        <p:nvPr/>
-      </p:nvGrpSpPr>
-      <p:grpSpPr>
-        <a:xfrm>
-          <a:off x="0" y="0"/>
-          <a:ext cx="0" cy="0"/>
-          <a:chOff x="0" y="0"/>
-          <a:chExt cx="0" cy="0"/>
-        </a:xfrm>
-      </p:grpSpPr>
-      <p:pic>
-        <p:nvPicPr>
-          <p:cNvPr id="4" name="Picture 3"/>
-          <p:cNvPicPr/>
-          <p:nvPr/>
-        </p:nvPicPr>
-        <p:blipFill>
-          <a:blip r:embed="rId2"/>
-          <a:stretch>
-            <a:fillRect/>
-          </a:stretch>
-        </p:blipFill>
-        <p:spPr>
-          <a:xfrm>
-            <a:off x="3422332" y="1609725"/>
-            <a:ext cx="5347335" cy="3638550"/>
-          </a:xfrm>
-          <a:prstGeom prst="rect">
-            <a:avLst/>
-          </a:prstGeom>
-        </p:spPr>
-      </p:pic>
-      <p:pic>
-        <p:nvPicPr>
-          <p:cNvPr id="5" name="Picture 4"/>
-          <p:cNvPicPr/>
-          <p:nvPr/>
-        </p:nvPicPr>
-        <p:blipFill>
-          <a:blip r:embed="rId2"/>
-          <a:stretch>
-            <a:fillRect/>
-          </a:stretch>
-        </p:blipFill>
-        <p:spPr>
-          <a:xfrm>
-            <a:off x="919765" y="0"/>
-            <a:ext cx="10078745" cy="6858000"/>
-          </a:xfrm>
-          <a:prstGeom prst="rect">
-            <a:avLst/>
-          </a:prstGeom>
-        </p:spPr>
-      </p:pic>
-    </p:spTree>
-    <p:extLst>
-      <p:ext uri="{BB962C8B-B14F-4D97-AF65-F5344CB8AC3E}">
-        <p14:creationId xmlns:p14="http://schemas.microsoft.com/office/powerpoint/2010/main" val="3689277141"/>
-      </p:ext>
-    </p:extLst>
-  </p:cSld>
-  <p:clrMapOvr>
-    <a:masterClrMapping/>
-  </p:clrMapOvr>
-  <p:timing>
-    <p:tnLst>
-      <p:par>
-        <p:cTn id="1" dur="indefinite" restart="never" nodeType="tmRoot"/>
-      </p:par>
-    </p:tnLst>
-  </p:timing>
-</p:sld>
-</file>
-
-<file path=ppt/slides/slide15.xml><?xml version="1.0" encoding="utf-8"?>
-<p:sld xmlns:a="http://schemas.openxmlformats.org/drawingml/2006/main" xmlns:r="http://schemas.openxmlformats.org/officeDocument/2006/relationships" xmlns:p="http://schemas.openxmlformats.org/presentationml/2006/main">
-  <p:cSld>
-    <p:spTree>
-      <p:nvGrpSpPr>
-        <p:cNvPr id="1" name=""/>
-        <p:cNvGrpSpPr/>
-        <p:nvPr/>
-      </p:nvGrpSpPr>
-      <p:grpSpPr>
-        <a:xfrm>
-          <a:off x="0" y="0"/>
-          <a:ext cx="0" cy="0"/>
-          <a:chOff x="0" y="0"/>
-          <a:chExt cx="0" cy="0"/>
-        </a:xfrm>
-      </p:grpSpPr>
-      <p:pic>
-        <p:nvPicPr>
-          <p:cNvPr id="5" name="Picture 4"/>
-          <p:cNvPicPr>
-            <a:picLocks noChangeAspect="1"/>
-          </p:cNvPicPr>
-          <p:nvPr/>
-        </p:nvPicPr>
-        <p:blipFill>
-          <a:blip r:embed="rId2">
-            <a:extLst>
-              <a:ext uri="{28A0092B-C50C-407E-A947-70E740481C1C}">
-                <a14:useLocalDpi xmlns:a14="http://schemas.microsoft.com/office/drawing/2010/main" val="0"/>
-              </a:ext>
-            </a:extLst>
-          </a:blip>
-          <a:stretch>
-            <a:fillRect/>
-          </a:stretch>
-        </p:blipFill>
-        <p:spPr>
-          <a:xfrm>
-            <a:off x="1251750" y="0"/>
-            <a:ext cx="9144000" cy="6858000"/>
-          </a:xfrm>
-          <a:prstGeom prst="rect">
-            <a:avLst/>
-          </a:prstGeom>
-        </p:spPr>
-      </p:pic>
-    </p:spTree>
-    <p:extLst>
-      <p:ext uri="{BB962C8B-B14F-4D97-AF65-F5344CB8AC3E}">
-        <p14:creationId xmlns:p14="http://schemas.microsoft.com/office/powerpoint/2010/main" val="2752982984"/>
-      </p:ext>
-    </p:extLst>
-  </p:cSld>
-  <p:clrMapOvr>
-    <a:masterClrMapping/>
-  </p:clrMapOvr>
-  <p:timing>
-    <p:tnLst>
-      <p:par>
-        <p:cTn id="1" dur="indefinite" restart="never" nodeType="tmRoot"/>
-      </p:par>
-    </p:tnLst>
-  </p:timing>
-</p:sld>
-</file>
-
-<file path=ppt/slides/slide16.xml><?xml version="1.0" encoding="utf-8"?>
-<p:sld xmlns:a="http://schemas.openxmlformats.org/drawingml/2006/main" xmlns:r="http://schemas.openxmlformats.org/officeDocument/2006/relationships" xmlns:p="http://schemas.openxmlformats.org/presentationml/2006/main">
-  <p:cSld>
-    <p:spTree>
-      <p:nvGrpSpPr>
-        <p:cNvPr id="1" name=""/>
-        <p:cNvGrpSpPr/>
-        <p:nvPr/>
-      </p:nvGrpSpPr>
-      <p:grpSpPr>
-        <a:xfrm>
-          <a:off x="0" y="0"/>
-          <a:ext cx="0" cy="0"/>
-          <a:chOff x="0" y="0"/>
-          <a:chExt cx="0" cy="0"/>
-        </a:xfrm>
-      </p:grpSpPr>
-      <p:sp>
-        <p:nvSpPr>
-          <p:cNvPr id="2" name="Title 1"/>
-          <p:cNvSpPr>
-            <a:spLocks noGrp="1"/>
-          </p:cNvSpPr>
-          <p:nvPr>
-            <p:ph type="title"/>
-          </p:nvPr>
-        </p:nvSpPr>
-        <p:spPr>
-          <a:xfrm>
-            <a:off x="838200" y="514488"/>
-            <a:ext cx="10515600" cy="1325563"/>
-          </a:xfrm>
-        </p:spPr>
-        <p:txBody>
-          <a:bodyPr/>
-          <a:lstStyle/>
-          <a:p>
-            <a:pPr algn="ctr"/>
-            <a:r>
-              <a:rPr lang="hy-AM" dirty="0"/>
-              <a:t>EAD </a:t>
-            </a:r>
-            <a:r>
-              <a:rPr lang="hy-AM" dirty="0" smtClean="0"/>
-              <a:t>Գործակցի Բանաձևը</a:t>
-            </a:r>
-            <a:endParaRPr lang="ru-RU" dirty="0"/>
-          </a:p>
-        </p:txBody>
-      </p:sp>
-      <mc:AlternateContent xmlns:mc="http://schemas.openxmlformats.org/markup-compatibility/2006">
-        <mc:Choice xmlns:a14="http://schemas.microsoft.com/office/drawing/2010/main" Requires="a14">
-          <p:sp>
-            <p:nvSpPr>
-              <p:cNvPr id="3" name="Content Placeholder 2"/>
-              <p:cNvSpPr>
-                <a:spLocks noGrp="1"/>
-              </p:cNvSpPr>
-              <p:nvPr>
-                <p:ph idx="1"/>
-              </p:nvPr>
-            </p:nvSpPr>
-            <p:spPr>
-              <a:xfrm>
-                <a:off x="950495" y="1954430"/>
-                <a:ext cx="10515600" cy="757777"/>
-              </a:xfrm>
-            </p:spPr>
-            <p:txBody>
-              <a:bodyPr>
-                <a:normAutofit/>
-              </a:bodyPr>
-              <a:lstStyle/>
-              <a:p>
-                <a:pPr marL="0" indent="0">
-                  <a:buNone/>
-                </a:pPr>
-                <a14:m>
-                  <m:oMathPara xmlns:m="http://schemas.openxmlformats.org/officeDocument/2006/math">
-                    <m:oMathParaPr>
-                      <m:jc m:val="centerGroup"/>
-                    </m:oMathParaPr>
-                    <m:oMath xmlns:m="http://schemas.openxmlformats.org/officeDocument/2006/math">
-                      <m:r>
-                        <a:rPr lang="hy-AM" sz="3200" i="1" smtClean="0">
-                          <a:latin typeface="Cambria Math" panose="02040503050406030204" pitchFamily="18" charset="0"/>
-                        </a:rPr>
-                        <m:t>𝐸𝐴𝐷</m:t>
-                      </m:r>
-                      <m:r>
-                        <a:rPr lang="hy-AM" sz="3200" i="1" smtClean="0">
-                          <a:latin typeface="Cambria Math" panose="02040503050406030204" pitchFamily="18" charset="0"/>
-                        </a:rPr>
-                        <m:t>=</m:t>
-                      </m:r>
-                      <m:r>
-                        <a:rPr lang="en-US" sz="3200" i="1">
-                          <a:latin typeface="Cambria Math" panose="02040503050406030204" pitchFamily="18" charset="0"/>
-                        </a:rPr>
-                        <m:t>𝑂𝑢𝑡𝑠𝑡𝑎𝑛𝑑𝑖𝑛𝑔</m:t>
-                      </m:r>
-                      <m:r>
-                        <a:rPr lang="en-US" sz="3200" i="1">
-                          <a:latin typeface="Cambria Math" panose="02040503050406030204" pitchFamily="18" charset="0"/>
-                        </a:rPr>
-                        <m:t> </m:t>
-                      </m:r>
-                      <m:r>
-                        <a:rPr lang="en-US" sz="3200" i="1">
-                          <a:latin typeface="Cambria Math" panose="02040503050406030204" pitchFamily="18" charset="0"/>
-                        </a:rPr>
-                        <m:t>𝐵𝑎𝑙𝑎𝑛𝑐𝑒</m:t>
-                      </m:r>
-                      <m:r>
-                        <a:rPr lang="en-US" sz="3200" i="1">
-                          <a:latin typeface="Cambria Math" panose="02040503050406030204" pitchFamily="18" charset="0"/>
-                        </a:rPr>
-                        <m:t> + (</m:t>
-                      </m:r>
-                      <m:r>
-                        <a:rPr lang="en-US" sz="3200" i="1">
-                          <a:latin typeface="Cambria Math" panose="02040503050406030204" pitchFamily="18" charset="0"/>
-                        </a:rPr>
-                        <m:t>𝐶𝑟𝑒𝑑𝑖𝑡</m:t>
-                      </m:r>
-                      <m:r>
-                        <a:rPr lang="en-US" sz="3200" i="1">
-                          <a:latin typeface="Cambria Math" panose="02040503050406030204" pitchFamily="18" charset="0"/>
-                        </a:rPr>
-                        <m:t> </m:t>
-                      </m:r>
-                      <m:r>
-                        <a:rPr lang="en-US" sz="3200" i="1">
-                          <a:latin typeface="Cambria Math" panose="02040503050406030204" pitchFamily="18" charset="0"/>
-                        </a:rPr>
-                        <m:t>𝐿𝑖𝑚𝑖𝑡</m:t>
-                      </m:r>
-                      <m:r>
-                        <a:rPr lang="en-US" sz="3200" i="1">
-                          <a:latin typeface="Cambria Math" panose="02040503050406030204" pitchFamily="18" charset="0"/>
-                        </a:rPr>
-                        <m:t> </m:t>
-                      </m:r>
-                      <m:r>
-                        <a:rPr lang="en-US" sz="3200" i="1">
-                          <a:latin typeface="Cambria Math" panose="02040503050406030204" pitchFamily="18" charset="0"/>
-                        </a:rPr>
-                        <m:t>𝑥</m:t>
-                      </m:r>
-                      <m:r>
-                        <a:rPr lang="en-US" sz="3200" i="1">
-                          <a:latin typeface="Cambria Math" panose="02040503050406030204" pitchFamily="18" charset="0"/>
-                        </a:rPr>
-                        <m:t> </m:t>
-                      </m:r>
-                      <m:r>
-                        <a:rPr lang="en-US" sz="3200" i="1">
-                          <a:latin typeface="Cambria Math" panose="02040503050406030204" pitchFamily="18" charset="0"/>
-                        </a:rPr>
-                        <m:t>𝐶𝐶𝐹</m:t>
-                      </m:r>
-                      <m:r>
-                        <a:rPr lang="en-US" sz="3200" i="1">
-                          <a:latin typeface="Cambria Math" panose="02040503050406030204" pitchFamily="18" charset="0"/>
-                        </a:rPr>
-                        <m:t>)</m:t>
-                      </m:r>
-                    </m:oMath>
-                  </m:oMathPara>
-                </a14:m>
-                <a:endParaRPr lang="ru-RU" sz="3200" dirty="0"/>
-              </a:p>
-            </p:txBody>
-          </p:sp>
-        </mc:Choice>
-        <mc:Fallback>
-          <p:sp>
-            <p:nvSpPr>
-              <p:cNvPr id="3" name="Content Placeholder 2"/>
-              <p:cNvSpPr>
-                <a:spLocks noGrp="1" noRot="1" noChangeAspect="1" noMove="1" noResize="1" noEditPoints="1" noAdjustHandles="1" noChangeArrowheads="1" noChangeShapeType="1" noTextEdit="1"/>
-              </p:cNvSpPr>
-              <p:nvPr>
-                <p:ph idx="1"/>
-              </p:nvPr>
-            </p:nvSpPr>
-            <p:spPr>
-              <a:xfrm>
-                <a:off x="950495" y="1954430"/>
-                <a:ext cx="10515600" cy="757777"/>
-              </a:xfrm>
-              <a:blipFill>
-                <a:blip r:embed="rId2"/>
-                <a:stretch>
-                  <a:fillRect/>
-                </a:stretch>
-              </a:blipFill>
-            </p:spPr>
-            <p:txBody>
-              <a:bodyPr/>
-              <a:lstStyle/>
-              <a:p>
-                <a:r>
-                  <a:rPr lang="ru-RU">
-                    <a:noFill/>
-                  </a:rPr>
-                  <a:t> </a:t>
-                </a:r>
-              </a:p>
-            </p:txBody>
-          </p:sp>
-        </mc:Fallback>
-      </mc:AlternateContent>
-      <p:sp>
-        <p:nvSpPr>
-          <p:cNvPr id="4" name="TextBox 3"/>
-          <p:cNvSpPr txBox="1"/>
-          <p:nvPr/>
-        </p:nvSpPr>
-        <p:spPr>
-          <a:xfrm>
-            <a:off x="1315453" y="2826586"/>
-            <a:ext cx="10038347" cy="2246769"/>
-          </a:xfrm>
-          <a:prstGeom prst="rect">
-            <a:avLst/>
-          </a:prstGeom>
-          <a:noFill/>
-        </p:spPr>
-        <p:txBody>
-          <a:bodyPr wrap="square" rtlCol="0">
-            <a:spAutoFit/>
-          </a:bodyPr>
-          <a:lstStyle/>
-          <a:p>
-            <a:r>
-              <a:rPr lang="en-US" sz="2800" dirty="0"/>
-              <a:t>•	Outstanding Balance - </a:t>
-            </a:r>
-            <a:r>
-              <a:rPr lang="hy-AM" sz="2800" dirty="0"/>
-              <a:t>ընթացիկ պարտք,</a:t>
-            </a:r>
-          </a:p>
-          <a:p>
-            <a:r>
-              <a:rPr lang="hy-AM" sz="2800" dirty="0"/>
-              <a:t>•	</a:t>
-            </a:r>
-            <a:r>
-              <a:rPr lang="en-US" sz="2800" dirty="0"/>
-              <a:t>Credit Limit - </a:t>
-            </a:r>
-            <a:r>
-              <a:rPr lang="hy-AM" sz="2800" dirty="0"/>
-              <a:t>վարկային սահմանաչափ,</a:t>
-            </a:r>
-          </a:p>
-          <a:p>
-            <a:r>
-              <a:rPr lang="hy-AM" sz="2800" dirty="0"/>
-              <a:t>•	</a:t>
-            </a:r>
-            <a:r>
-              <a:rPr lang="en-US" sz="2800" dirty="0"/>
-              <a:t>CCF </a:t>
-            </a:r>
-            <a:r>
-              <a:rPr lang="en-US" sz="2800" dirty="0" smtClean="0"/>
-              <a:t>- </a:t>
-            </a:r>
-            <a:r>
-              <a:rPr lang="hy-AM" sz="2800" dirty="0"/>
-              <a:t>վարկային </a:t>
-            </a:r>
-            <a:r>
-              <a:rPr lang="hy-AM" sz="2800" dirty="0" smtClean="0"/>
-              <a:t>փոխակերպման</a:t>
-            </a:r>
-            <a:r>
-              <a:rPr lang="en-US" sz="2800" dirty="0" smtClean="0"/>
-              <a:t> </a:t>
-            </a:r>
-            <a:r>
-              <a:rPr lang="hy-AM" sz="2800" dirty="0" smtClean="0"/>
-              <a:t>գործակից </a:t>
-            </a:r>
-            <a:endParaRPr lang="en-US" sz="2800" dirty="0" smtClean="0"/>
-          </a:p>
-          <a:p>
-            <a:r>
-              <a:rPr lang="hy-AM" sz="2800" dirty="0" smtClean="0"/>
-              <a:t>•	Գործնական նշանակությունը.</a:t>
-            </a:r>
-          </a:p>
-          <a:p>
-            <a:endParaRPr lang="ru-RU" sz="2800" dirty="0"/>
-          </a:p>
-        </p:txBody>
-      </p:sp>
-    </p:spTree>
-    <p:extLst>
-      <p:ext uri="{BB962C8B-B14F-4D97-AF65-F5344CB8AC3E}">
-        <p14:creationId xmlns:p14="http://schemas.microsoft.com/office/powerpoint/2010/main" val="1495527178"/>
-      </p:ext>
-    </p:extLst>
-  </p:cSld>
-  <p:clrMapOvr>
-    <a:masterClrMapping/>
-  </p:clrMapOvr>
-  <p:timing>
-    <p:tnLst>
-      <p:par>
-        <p:cTn id="1" dur="indefinite" restart="never" nodeType="tmRoot"/>
-      </p:par>
-    </p:tnLst>
-  </p:timing>
-</p:sld>
-</file>
-
-<file path=ppt/slides/slide17.xml><?xml version="1.0" encoding="utf-8"?>
-<p:sld xmlns:a="http://schemas.openxmlformats.org/drawingml/2006/main" xmlns:r="http://schemas.openxmlformats.org/officeDocument/2006/relationships" xmlns:p="http://schemas.openxmlformats.org/presentationml/2006/main">
-  <p:cSld>
-    <p:spTree>
-      <p:nvGrpSpPr>
-        <p:cNvPr id="1" name=""/>
-        <p:cNvGrpSpPr/>
-        <p:nvPr/>
-      </p:nvGrpSpPr>
-      <p:grpSpPr>
-        <a:xfrm>
-          <a:off x="0" y="0"/>
-          <a:ext cx="0" cy="0"/>
-          <a:chOff x="0" y="0"/>
-          <a:chExt cx="0" cy="0"/>
-        </a:xfrm>
-      </p:grpSpPr>
-      <p:sp>
-        <p:nvSpPr>
-          <p:cNvPr id="4" name="Title 1"/>
-          <p:cNvSpPr>
-            <a:spLocks noGrp="1"/>
-          </p:cNvSpPr>
-          <p:nvPr>
-            <p:ph type="title"/>
-          </p:nvPr>
-        </p:nvSpPr>
-        <p:spPr>
-          <a:xfrm>
-            <a:off x="838200" y="651888"/>
-            <a:ext cx="10515600" cy="1325563"/>
-          </a:xfrm>
-        </p:spPr>
-        <p:txBody>
-          <a:bodyPr/>
-          <a:lstStyle/>
-          <a:p>
-            <a:pPr algn="ctr"/>
-            <a:r>
-              <a:rPr lang="en-US" dirty="0" smtClean="0"/>
-              <a:t>LGD</a:t>
-            </a:r>
-            <a:r>
-              <a:rPr lang="hy-AM" dirty="0" smtClean="0"/>
-              <a:t> </a:t>
-            </a:r>
-            <a:r>
-              <a:rPr lang="en-US" dirty="0" smtClean="0"/>
-              <a:t>(</a:t>
-            </a:r>
-            <a:r>
-              <a:rPr lang="hy-AM" dirty="0"/>
-              <a:t>Կորուստը չվճարման դեպքում</a:t>
-            </a:r>
-            <a:r>
-              <a:rPr lang="en-US" dirty="0" smtClean="0"/>
-              <a:t>) </a:t>
-            </a:r>
-            <a:r>
-              <a:rPr lang="hy-AM" dirty="0" smtClean="0"/>
-              <a:t>Գործակցի </a:t>
-            </a:r>
-            <a:r>
-              <a:rPr lang="hy-AM" dirty="0" smtClean="0"/>
-              <a:t>Բանաձևը</a:t>
-            </a:r>
-            <a:endParaRPr lang="ru-RU" dirty="0"/>
-          </a:p>
-        </p:txBody>
-      </p:sp>
-      <mc:AlternateContent xmlns:mc="http://schemas.openxmlformats.org/markup-compatibility/2006">
-        <mc:Choice xmlns:a14="http://schemas.microsoft.com/office/drawing/2010/main" Requires="a14">
-          <p:sp>
-            <p:nvSpPr>
-              <p:cNvPr id="5" name="Content Placeholder 2"/>
-              <p:cNvSpPr>
-                <a:spLocks noGrp="1"/>
-              </p:cNvSpPr>
-              <p:nvPr>
-                <p:ph idx="1"/>
-              </p:nvPr>
-            </p:nvSpPr>
-            <p:spPr>
-              <a:xfrm>
-                <a:off x="838200" y="2696899"/>
-                <a:ext cx="10515600" cy="757777"/>
-              </a:xfrm>
-            </p:spPr>
-            <p:txBody>
-              <a:bodyPr>
-                <a:normAutofit/>
-              </a:bodyPr>
-              <a:lstStyle/>
-              <a:p>
-                <a:pPr marL="0" indent="0">
-                  <a:buNone/>
-                </a:pPr>
-                <a14:m>
-                  <m:oMathPara xmlns:m="http://schemas.openxmlformats.org/officeDocument/2006/math">
-                    <m:oMathParaPr>
-                      <m:jc m:val="centerGroup"/>
-                    </m:oMathParaPr>
-                    <m:oMath xmlns:m="http://schemas.openxmlformats.org/officeDocument/2006/math">
-                      <m:r>
-                        <a:rPr lang="ru-RU" sz="4400" b="0" i="1" smtClean="0">
-                          <a:latin typeface="Cambria Math" panose="02040503050406030204" pitchFamily="18" charset="0"/>
-                        </a:rPr>
-                        <m:t>𝐿𝐺𝐷</m:t>
-                      </m:r>
-                      <m:r>
-                        <a:rPr lang="ru-RU" sz="4400" b="0" i="1" smtClean="0">
-                          <a:latin typeface="Cambria Math" panose="02040503050406030204" pitchFamily="18" charset="0"/>
-                        </a:rPr>
-                        <m:t> = 1 −</m:t>
-                      </m:r>
-                      <m:r>
-                        <a:rPr lang="en-US" sz="4400" b="0" i="1" smtClean="0">
-                          <a:latin typeface="Cambria Math" panose="02040503050406030204" pitchFamily="18" charset="0"/>
-                        </a:rPr>
-                        <m:t>𝑅𝑒𝑐𝑜𝑣𝑒𝑟𝑦</m:t>
-                      </m:r>
-                      <m:r>
-                        <a:rPr lang="en-US" sz="4400" b="0" i="1" smtClean="0">
-                          <a:latin typeface="Cambria Math" panose="02040503050406030204" pitchFamily="18" charset="0"/>
-                        </a:rPr>
-                        <m:t> </m:t>
-                      </m:r>
-                      <m:r>
-                        <a:rPr lang="en-US" sz="4400" b="0" i="1" smtClean="0">
-                          <a:latin typeface="Cambria Math" panose="02040503050406030204" pitchFamily="18" charset="0"/>
-                        </a:rPr>
-                        <m:t>𝑅𝑎𝑡𝑒</m:t>
-                      </m:r>
-                    </m:oMath>
-                  </m:oMathPara>
-                </a14:m>
-                <a:endParaRPr lang="ru-RU" sz="4400" dirty="0"/>
-              </a:p>
-            </p:txBody>
-          </p:sp>
-        </mc:Choice>
-        <mc:Fallback>
-          <p:sp>
-            <p:nvSpPr>
-              <p:cNvPr id="5" name="Content Placeholder 2"/>
-              <p:cNvSpPr>
-                <a:spLocks noGrp="1" noRot="1" noChangeAspect="1" noMove="1" noResize="1" noEditPoints="1" noAdjustHandles="1" noChangeArrowheads="1" noChangeShapeType="1" noTextEdit="1"/>
-              </p:cNvSpPr>
-              <p:nvPr>
-                <p:ph idx="1"/>
-              </p:nvPr>
-            </p:nvSpPr>
-            <p:spPr>
-              <a:xfrm>
-                <a:off x="838200" y="2696899"/>
-                <a:ext cx="10515600" cy="757777"/>
-              </a:xfrm>
-              <a:blipFill>
-                <a:blip r:embed="rId2"/>
-                <a:stretch>
-                  <a:fillRect/>
-                </a:stretch>
-              </a:blipFill>
-            </p:spPr>
-            <p:txBody>
-              <a:bodyPr/>
-              <a:lstStyle/>
-              <a:p>
-                <a:r>
-                  <a:rPr lang="ru-RU">
-                    <a:noFill/>
-                  </a:rPr>
-                  <a:t> </a:t>
-                </a:r>
-              </a:p>
-            </p:txBody>
-          </p:sp>
-        </mc:Fallback>
-      </mc:AlternateContent>
-      <p:sp>
-        <p:nvSpPr>
-          <p:cNvPr id="2" name="Rectangle 1"/>
-          <p:cNvSpPr/>
-          <p:nvPr/>
-        </p:nvSpPr>
-        <p:spPr>
-          <a:xfrm>
-            <a:off x="838200" y="4174124"/>
-            <a:ext cx="10804561" cy="523220"/>
-          </a:xfrm>
-          <a:prstGeom prst="rect">
-            <a:avLst/>
-          </a:prstGeom>
-        </p:spPr>
-        <p:txBody>
-          <a:bodyPr wrap="none">
-            <a:spAutoFit/>
-          </a:bodyPr>
-          <a:lstStyle/>
-          <a:p>
-            <a:r>
-              <a:rPr lang="en-US" sz="2800" dirty="0">
-                <a:latin typeface="Sylfaen" panose="010A0502050306030303" pitchFamily="18" charset="0"/>
-                <a:ea typeface="Calibri" panose="020F0502020204030204" pitchFamily="34" charset="0"/>
-                <a:cs typeface="Times New Roman" panose="02020603050405020304" pitchFamily="18" charset="0"/>
-              </a:rPr>
-              <a:t>Recovery </a:t>
-            </a:r>
-            <a:r>
-              <a:rPr lang="en-US" sz="2800" dirty="0" smtClean="0">
-                <a:latin typeface="Sylfaen" panose="010A0502050306030303" pitchFamily="18" charset="0"/>
-                <a:ea typeface="Calibri" panose="020F0502020204030204" pitchFamily="34" charset="0"/>
-                <a:cs typeface="Times New Roman" panose="02020603050405020304" pitchFamily="18" charset="0"/>
-              </a:rPr>
-              <a:t>Rate –</a:t>
-            </a:r>
-            <a:r>
-              <a:rPr lang="hy-AM" sz="2800" dirty="0" smtClean="0">
-                <a:latin typeface="Sylfaen" panose="010A0502050306030303" pitchFamily="18" charset="0"/>
-                <a:ea typeface="Calibri" panose="020F0502020204030204" pitchFamily="34" charset="0"/>
-                <a:cs typeface="Times New Roman" panose="02020603050405020304" pitchFamily="18" charset="0"/>
-              </a:rPr>
-              <a:t>վերականգնվող գումարի տոկոսը դեֆոլտից հետո</a:t>
-            </a:r>
-            <a:endParaRPr lang="ru-RU" sz="2800" dirty="0"/>
-          </a:p>
-        </p:txBody>
-      </p:sp>
-    </p:spTree>
-    <p:extLst>
-      <p:ext uri="{BB962C8B-B14F-4D97-AF65-F5344CB8AC3E}">
-        <p14:creationId xmlns:p14="http://schemas.microsoft.com/office/powerpoint/2010/main" val="639266211"/>
-      </p:ext>
-    </p:extLst>
-  </p:cSld>
-  <p:clrMapOvr>
-    <a:masterClrMapping/>
-  </p:clrMapOvr>
-  <p:timing>
-    <p:tnLst>
-      <p:par>
-        <p:cTn id="1" dur="indefinite" restart="never" nodeType="tmRoot"/>
-      </p:par>
-    </p:tnLst>
-  </p:timing>
-</p:sld>
-</file>
-
-<file path=ppt/slides/slide18.xml><?xml version="1.0" encoding="utf-8"?>
-<p:sld xmlns:a="http://schemas.openxmlformats.org/drawingml/2006/main" xmlns:r="http://schemas.openxmlformats.org/officeDocument/2006/relationships" xmlns:p="http://schemas.openxmlformats.org/presentationml/2006/main">
-  <p:cSld>
-    <p:spTree>
-      <p:nvGrpSpPr>
-        <p:cNvPr id="1" name=""/>
-        <p:cNvGrpSpPr/>
-        <p:nvPr/>
-      </p:nvGrpSpPr>
-      <p:grpSpPr>
-        <a:xfrm>
-          <a:off x="0" y="0"/>
-          <a:ext cx="0" cy="0"/>
-          <a:chOff x="0" y="0"/>
-          <a:chExt cx="0" cy="0"/>
-        </a:xfrm>
-      </p:grpSpPr>
-      <p:sp>
-        <p:nvSpPr>
-          <p:cNvPr id="2" name="Title 1"/>
-          <p:cNvSpPr>
-            <a:spLocks noGrp="1"/>
-          </p:cNvSpPr>
-          <p:nvPr>
-            <p:ph type="title"/>
-          </p:nvPr>
-        </p:nvSpPr>
-        <p:spPr>
-          <a:xfrm>
-            <a:off x="485683" y="924419"/>
-            <a:ext cx="11238390" cy="1325563"/>
-          </a:xfrm>
-        </p:spPr>
-        <p:txBody>
-          <a:bodyPr/>
-          <a:lstStyle/>
-          <a:p>
-            <a:pPr algn="ctr"/>
-            <a:r>
-              <a:rPr lang="en-US" dirty="0" smtClean="0"/>
-              <a:t>ECL (Expected Credit Loss) </a:t>
-            </a:r>
-            <a:r>
-              <a:rPr lang="hy-AM" dirty="0" smtClean="0"/>
-              <a:t>Հաշվման Բանաձևը</a:t>
-            </a:r>
-            <a:endParaRPr lang="ru-RU" dirty="0"/>
-          </a:p>
-        </p:txBody>
-      </p:sp>
-      <mc:AlternateContent xmlns:mc="http://schemas.openxmlformats.org/markup-compatibility/2006" xmlns:a14="http://schemas.microsoft.com/office/drawing/2010/main">
-        <mc:Choice Requires="a14">
-          <p:sp>
-            <p:nvSpPr>
-              <p:cNvPr id="3" name="Content Placeholder 2"/>
-              <p:cNvSpPr>
-                <a:spLocks noGrp="1"/>
-              </p:cNvSpPr>
-              <p:nvPr>
-                <p:ph idx="1"/>
-              </p:nvPr>
-            </p:nvSpPr>
-            <p:spPr>
-              <a:xfrm>
-                <a:off x="1956787" y="3423606"/>
-                <a:ext cx="8030592" cy="784410"/>
-              </a:xfrm>
-            </p:spPr>
-            <p:txBody>
-              <a:bodyPr>
-                <a:normAutofit fontScale="92500"/>
-              </a:bodyPr>
-              <a:lstStyle/>
-              <a:p>
-                <a:pPr marL="0" indent="0">
-                  <a:buNone/>
-                </a:pPr>
-                <a14:m>
-                  <m:oMathPara xmlns:m="http://schemas.openxmlformats.org/officeDocument/2006/math">
-                    <m:oMathParaPr>
-                      <m:jc m:val="centerGroup"/>
-                    </m:oMathParaPr>
-                    <m:oMath xmlns:m="http://schemas.openxmlformats.org/officeDocument/2006/math">
-                      <m:r>
-                        <a:rPr lang="ru-RU" sz="5400" i="1">
-                          <a:latin typeface="Cambria Math" panose="02040503050406030204" pitchFamily="18" charset="0"/>
-                        </a:rPr>
-                        <m:t>𝐸𝐶𝐿</m:t>
-                      </m:r>
-                      <m:r>
-                        <a:rPr lang="ru-RU" sz="5400" i="1">
-                          <a:latin typeface="Cambria Math" panose="02040503050406030204" pitchFamily="18" charset="0"/>
-                        </a:rPr>
-                        <m:t>=</m:t>
-                      </m:r>
-                      <m:r>
-                        <a:rPr lang="ru-RU" sz="5400" i="1">
-                          <a:latin typeface="Cambria Math" panose="02040503050406030204" pitchFamily="18" charset="0"/>
-                        </a:rPr>
-                        <m:t>𝑃𝐷</m:t>
-                      </m:r>
-                      <m:r>
-                        <a:rPr lang="ru-RU" sz="5400" i="1">
-                          <a:latin typeface="Cambria Math" panose="02040503050406030204" pitchFamily="18" charset="0"/>
-                        </a:rPr>
-                        <m:t>×</m:t>
-                      </m:r>
-                      <m:r>
-                        <a:rPr lang="ru-RU" sz="5400" i="1">
-                          <a:latin typeface="Cambria Math" panose="02040503050406030204" pitchFamily="18" charset="0"/>
-                        </a:rPr>
-                        <m:t>𝐸𝐴𝐷</m:t>
-                      </m:r>
-                      <m:r>
-                        <a:rPr lang="ru-RU" sz="5400" i="1">
-                          <a:latin typeface="Cambria Math" panose="02040503050406030204" pitchFamily="18" charset="0"/>
-                        </a:rPr>
-                        <m:t>×</m:t>
-                      </m:r>
-                      <m:r>
-                        <a:rPr lang="ru-RU" sz="5400" i="1">
-                          <a:latin typeface="Cambria Math" panose="02040503050406030204" pitchFamily="18" charset="0"/>
-                        </a:rPr>
-                        <m:t>𝐿𝐺𝐷</m:t>
-                      </m:r>
-                    </m:oMath>
-                  </m:oMathPara>
-                </a14:m>
-                <a:endParaRPr lang="ru-RU" sz="5400" dirty="0"/>
-              </a:p>
-              <a:p>
-                <a:pPr marL="0" indent="0">
-                  <a:buNone/>
-                </a:pPr>
-                <a:endParaRPr lang="ru-RU" sz="5400" dirty="0"/>
-              </a:p>
-            </p:txBody>
-          </p:sp>
-        </mc:Choice>
-        <mc:Fallback xmlns="">
-          <p:sp>
-            <p:nvSpPr>
-              <p:cNvPr id="3" name="Content Placeholder 2"/>
-              <p:cNvSpPr>
-                <a:spLocks noGrp="1" noRot="1" noChangeAspect="1" noMove="1" noResize="1" noEditPoints="1" noAdjustHandles="1" noChangeArrowheads="1" noChangeShapeType="1" noTextEdit="1"/>
-              </p:cNvSpPr>
-              <p:nvPr>
-                <p:ph idx="1"/>
-              </p:nvPr>
-            </p:nvSpPr>
-            <p:spPr>
-              <a:xfrm>
-                <a:off x="1956787" y="3423606"/>
-                <a:ext cx="8030592" cy="784410"/>
-              </a:xfrm>
-              <a:blipFill>
-                <a:blip r:embed="rId2"/>
-                <a:stretch>
-                  <a:fillRect/>
-                </a:stretch>
-              </a:blipFill>
-            </p:spPr>
-            <p:txBody>
-              <a:bodyPr/>
-              <a:lstStyle/>
-              <a:p>
-                <a:r>
-                  <a:rPr lang="ru-RU">
-                    <a:noFill/>
-                  </a:rPr>
-                  <a:t> </a:t>
-                </a:r>
-              </a:p>
-            </p:txBody>
-          </p:sp>
-        </mc:Fallback>
-      </mc:AlternateContent>
-    </p:spTree>
-    <p:extLst>
-      <p:ext uri="{BB962C8B-B14F-4D97-AF65-F5344CB8AC3E}">
-        <p14:creationId xmlns:p14="http://schemas.microsoft.com/office/powerpoint/2010/main" val="1447601428"/>
-      </p:ext>
-    </p:extLst>
-  </p:cSld>
-  <p:clrMapOvr>
-    <a:masterClrMapping/>
-  </p:clrMapOvr>
-  <p:timing>
-    <p:tnLst>
-      <p:par>
-        <p:cTn id="1" dur="indefinite" restart="never" nodeType="tmRoot"/>
-      </p:par>
-    </p:tnLst>
-  </p:timing>
-</p:sld>
-</file>
-
-<file path=ppt/slides/slide19.xml><?xml version="1.0" encoding="utf-8"?>
-<p:sld xmlns:a="http://schemas.openxmlformats.org/drawingml/2006/main" xmlns:r="http://schemas.openxmlformats.org/officeDocument/2006/relationships" xmlns:p="http://schemas.openxmlformats.org/presentationml/2006/main">
-  <p:cSld>
-    <p:spTree>
-      <p:nvGrpSpPr>
-        <p:cNvPr id="1" name=""/>
-        <p:cNvGrpSpPr/>
-        <p:nvPr/>
-      </p:nvGrpSpPr>
-      <p:grpSpPr>
-        <a:xfrm>
-          <a:off x="0" y="0"/>
-          <a:ext cx="0" cy="0"/>
-          <a:chOff x="0" y="0"/>
-          <a:chExt cx="0" cy="0"/>
-        </a:xfrm>
-      </p:grpSpPr>
-      <p:sp>
-        <p:nvSpPr>
-          <p:cNvPr id="2" name="Title 1"/>
-          <p:cNvSpPr>
-            <a:spLocks noGrp="1"/>
-          </p:cNvSpPr>
-          <p:nvPr>
-            <p:ph type="title"/>
-          </p:nvPr>
-        </p:nvSpPr>
-        <p:spPr>
-          <a:xfrm>
-            <a:off x="795512" y="0"/>
-            <a:ext cx="10515600" cy="1325563"/>
-          </a:xfrm>
-        </p:spPr>
-        <p:txBody>
-          <a:bodyPr/>
-          <a:lstStyle/>
-          <a:p>
-            <a:pPr algn="ctr"/>
-            <a:r>
-              <a:rPr lang="en-US" dirty="0" smtClean="0"/>
-              <a:t>ECL-</a:t>
-            </a:r>
-            <a:r>
-              <a:rPr lang="hy-AM" dirty="0" smtClean="0"/>
-              <a:t>ի Հաշվարկման Ալգորիթմը</a:t>
-            </a:r>
-            <a:endParaRPr lang="ru-RU" dirty="0"/>
-          </a:p>
-        </p:txBody>
-      </p:sp>
-      <p:pic>
-        <p:nvPicPr>
-          <p:cNvPr id="4" name="Picture 3"/>
-          <p:cNvPicPr/>
-          <p:nvPr/>
-        </p:nvPicPr>
-        <p:blipFill>
-          <a:blip r:embed="rId2"/>
-          <a:stretch>
-            <a:fillRect/>
-          </a:stretch>
-        </p:blipFill>
-        <p:spPr>
-          <a:xfrm>
-            <a:off x="1917056" y="1322787"/>
-            <a:ext cx="4136256" cy="5060466"/>
-          </a:xfrm>
-          <a:prstGeom prst="rect">
-            <a:avLst/>
-          </a:prstGeom>
-        </p:spPr>
-      </p:pic>
-      <p:pic>
-        <p:nvPicPr>
-          <p:cNvPr id="5" name="Picture 4"/>
-          <p:cNvPicPr/>
-          <p:nvPr/>
-        </p:nvPicPr>
-        <p:blipFill>
-          <a:blip r:embed="rId3"/>
-          <a:stretch>
-            <a:fillRect/>
-          </a:stretch>
-        </p:blipFill>
-        <p:spPr>
-          <a:xfrm>
-            <a:off x="7083214" y="1478630"/>
-            <a:ext cx="2301418" cy="4748780"/>
-          </a:xfrm>
-          <a:prstGeom prst="rect">
-            <a:avLst/>
-          </a:prstGeom>
-        </p:spPr>
-      </p:pic>
-    </p:spTree>
-    <p:extLst>
-      <p:ext uri="{BB962C8B-B14F-4D97-AF65-F5344CB8AC3E}">
-        <p14:creationId xmlns:p14="http://schemas.microsoft.com/office/powerpoint/2010/main" val="2822845314"/>
-      </p:ext>
-    </p:extLst>
-  </p:cSld>
-  <p:clrMapOvr>
-    <a:masterClrMapping/>
-  </p:clrMapOvr>
-  <p:timing>
-    <p:tnLst>
-      <p:par>
-        <p:cTn id="1" dur="indefinite" restart="never" nodeType="tmRoot"/>
-      </p:par>
-    </p:tnLst>
-  </p:timing>
-</p:sld>
-</file>
-
-<file path=ppt/slides/slide2.xml><?xml version="1.0" encoding="utf-8"?>
-<p:sld xmlns:a="http://schemas.openxmlformats.org/drawingml/2006/main" xmlns:r="http://schemas.openxmlformats.org/officeDocument/2006/relationships" xmlns:p="http://schemas.openxmlformats.org/presentationml/2006/main">
-  <p:cSld>
-    <p:spTree>
-      <p:nvGrpSpPr>
-        <p:cNvPr id="1" name=""/>
-        <p:cNvGrpSpPr/>
-        <p:nvPr/>
-      </p:nvGrpSpPr>
-      <p:grpSpPr>
-        <a:xfrm>
-          <a:off x="0" y="0"/>
-          <a:ext cx="0" cy="0"/>
-          <a:chOff x="0" y="0"/>
-          <a:chExt cx="0" cy="0"/>
-        </a:xfrm>
-      </p:grpSpPr>
-      <p:sp>
-        <p:nvSpPr>
-          <p:cNvPr id="2" name="Title 1"/>
-          <p:cNvSpPr>
-            <a:spLocks noGrp="1"/>
-          </p:cNvSpPr>
-          <p:nvPr>
-            <p:ph type="title"/>
-          </p:nvPr>
-        </p:nvSpPr>
-        <p:spPr/>
-        <p:txBody>
-          <a:bodyPr/>
-          <a:lstStyle/>
-          <a:p>
-            <a:pPr algn="ctr"/>
-            <a:r>
-              <a:rPr lang="hy-AM" dirty="0" smtClean="0">
-                <a:latin typeface="Stylafen"/>
-              </a:rPr>
-              <a:t>Խնդրի Դրվածք</a:t>
-            </a:r>
-            <a:br>
-              <a:rPr lang="hy-AM" dirty="0" smtClean="0">
-                <a:latin typeface="Stylafen"/>
-              </a:rPr>
-            </a:br>
-            <a:r>
-              <a:rPr lang="hy-AM" sz="3600" dirty="0" smtClean="0">
-                <a:latin typeface="Stylafen"/>
-              </a:rPr>
-              <a:t>Վարկային ռիսկի մոդելավորում</a:t>
-            </a:r>
-            <a:r>
-              <a:rPr lang="en-US" sz="3600" dirty="0" smtClean="0">
-                <a:latin typeface="Stylafen"/>
-              </a:rPr>
-              <a:t> </a:t>
-            </a:r>
-            <a:endParaRPr lang="ru-RU" sz="3600" dirty="0">
-              <a:latin typeface="Stylafen"/>
-            </a:endParaRPr>
-          </a:p>
-        </p:txBody>
-      </p:sp>
-      <p:pic>
-        <p:nvPicPr>
-          <p:cNvPr id="3" name="Picture 2"/>
-          <p:cNvPicPr>
-            <a:picLocks noChangeAspect="1"/>
-          </p:cNvPicPr>
-          <p:nvPr/>
-        </p:nvPicPr>
-        <p:blipFill>
-          <a:blip r:embed="rId2">
-            <a:extLst>
-              <a:ext uri="{28A0092B-C50C-407E-A947-70E740481C1C}">
-                <a14:useLocalDpi xmlns:a14="http://schemas.microsoft.com/office/drawing/2010/main" val="0"/>
-              </a:ext>
-            </a:extLst>
-          </a:blip>
-          <a:stretch>
-            <a:fillRect/>
-          </a:stretch>
-        </p:blipFill>
-        <p:spPr>
-          <a:xfrm>
-            <a:off x="1192936" y="1992529"/>
-            <a:ext cx="9806127" cy="4118574"/>
-          </a:xfrm>
-          <a:prstGeom prst="rect">
-            <a:avLst/>
-          </a:prstGeom>
-        </p:spPr>
-      </p:pic>
-    </p:spTree>
-    <p:extLst>
-      <p:ext uri="{BB962C8B-B14F-4D97-AF65-F5344CB8AC3E}">
-        <p14:creationId xmlns:p14="http://schemas.microsoft.com/office/powerpoint/2010/main" val="1881218511"/>
-      </p:ext>
-    </p:extLst>
-  </p:cSld>
-  <p:clrMapOvr>
-    <a:masterClrMapping/>
-  </p:clrMapOvr>
-  <p:timing>
-    <p:tnLst>
-      <p:par>
-        <p:cTn id="1" dur="indefinite" restart="never" nodeType="tmRoot"/>
-      </p:par>
-    </p:tnLst>
-  </p:timing>
-</p:sld>
-</file>
-
-<file path=ppt/slides/slide20.xml><?xml version="1.0" encoding="utf-8"?>
-<p:sld xmlns:a="http://schemas.openxmlformats.org/drawingml/2006/main" xmlns:r="http://schemas.openxmlformats.org/officeDocument/2006/relationships" xmlns:p="http://schemas.openxmlformats.org/presentationml/2006/main">
-  <p:cSld>
-    <p:spTree>
-      <p:nvGrpSpPr>
-        <p:cNvPr id="1" name=""/>
-        <p:cNvGrpSpPr/>
-        <p:nvPr/>
-      </p:nvGrpSpPr>
-      <p:grpSpPr>
-        <a:xfrm>
-          <a:off x="0" y="0"/>
-          <a:ext cx="0" cy="0"/>
-          <a:chOff x="0" y="0"/>
-          <a:chExt cx="0" cy="0"/>
-        </a:xfrm>
-      </p:grpSpPr>
-      <p:sp>
-        <p:nvSpPr>
-          <p:cNvPr id="2" name="Title 1"/>
-          <p:cNvSpPr>
-            <a:spLocks noGrp="1"/>
-          </p:cNvSpPr>
-          <p:nvPr>
-            <p:ph type="title"/>
-          </p:nvPr>
-        </p:nvSpPr>
-        <p:spPr>
-          <a:xfrm>
-            <a:off x="918099" y="2318212"/>
-            <a:ext cx="10515600" cy="1325563"/>
-          </a:xfrm>
-        </p:spPr>
-        <p:txBody>
-          <a:bodyPr>
-            <a:normAutofit/>
-          </a:bodyPr>
-          <a:lstStyle/>
-          <a:p>
-            <a:pPr algn="ctr"/>
-            <a:r>
-              <a:rPr lang="hy-AM" sz="6000" dirty="0" smtClean="0">
-                <a:latin typeface="Stylafen"/>
-              </a:rPr>
-              <a:t>Շնորհակալություն</a:t>
-            </a:r>
-            <a:endParaRPr lang="ru-RU" sz="4800" dirty="0">
-              <a:latin typeface="Stylafen"/>
-            </a:endParaRPr>
-          </a:p>
-        </p:txBody>
-      </p:sp>
-    </p:spTree>
-    <p:extLst>
-      <p:ext uri="{BB962C8B-B14F-4D97-AF65-F5344CB8AC3E}">
-        <p14:creationId xmlns:p14="http://schemas.microsoft.com/office/powerpoint/2010/main" val="2486254819"/>
-      </p:ext>
-    </p:extLst>
-  </p:cSld>
-  <p:clrMapOvr>
-    <a:masterClrMapping/>
-  </p:clrMapOvr>
-  <p:timing>
-    <p:tnLst>
-      <p:par>
-        <p:cTn id="1" dur="indefinite" restart="never" nodeType="tmRoot"/>
-      </p:par>
-    </p:tnLst>
-  </p:timing>
-</p:sld>
-</file>
-
-<file path=ppt/slides/slide3.xml><?xml version="1.0" encoding="utf-8"?>
-<p:sld xmlns:a="http://schemas.openxmlformats.org/drawingml/2006/main" xmlns:r="http://schemas.openxmlformats.org/officeDocument/2006/relationships" xmlns:p="http://schemas.openxmlformats.org/presentationml/2006/main">
-  <p:cSld>
-    <p:spTree>
-      <p:nvGrpSpPr>
-        <p:cNvPr id="1" name=""/>
-        <p:cNvGrpSpPr/>
-        <p:nvPr/>
-      </p:nvGrpSpPr>
-      <p:grpSpPr>
-        <a:xfrm>
-          <a:off x="0" y="0"/>
-          <a:ext cx="0" cy="0"/>
-          <a:chOff x="0" y="0"/>
-          <a:chExt cx="0" cy="0"/>
-        </a:xfrm>
-      </p:grpSpPr>
-      <p:sp>
-        <p:nvSpPr>
-          <p:cNvPr id="4" name="Title 1"/>
-          <p:cNvSpPr txBox="1">
-            <a:spLocks/>
-          </p:cNvSpPr>
-          <p:nvPr/>
-        </p:nvSpPr>
-        <p:spPr>
-          <a:xfrm>
-            <a:off x="838200" y="365125"/>
-            <a:ext cx="10515600" cy="1325563"/>
-          </a:xfrm>
-          <a:prstGeom prst="rect">
-            <a:avLst/>
-          </a:prstGeom>
-        </p:spPr>
-        <p:txBody>
-          <a:bodyPr vert="horz" lIns="91440" tIns="45720" rIns="91440" bIns="45720" rtlCol="0" anchor="ctr">
-            <a:normAutofit/>
-          </a:bodyPr>
-          <a:lstStyle>
-            <a:lvl1pPr algn="l" defTabSz="914400" rtl="0" eaLnBrk="1" latinLnBrk="0" hangingPunct="1">
-              <a:lnSpc>
-                <a:spcPct val="90000"/>
-              </a:lnSpc>
-              <a:spcBef>
-                <a:spcPct val="0"/>
-              </a:spcBef>
-              <a:buNone/>
-              <a:defRPr sz="4400" kern="1200">
-                <a:solidFill>
-                  <a:schemeClr val="tx1"/>
-                </a:solidFill>
-                <a:latin typeface="+mj-lt"/>
-                <a:ea typeface="+mj-ea"/>
-                <a:cs typeface="+mj-cs"/>
-              </a:defRPr>
-            </a:lvl1pPr>
-          </a:lstStyle>
-          <a:p>
-            <a:pPr algn="ctr"/>
-            <a:r>
-              <a:rPr lang="hy-AM" dirty="0" smtClean="0"/>
-              <a:t>Տեղեկատվական Տեխնոլոգիաների Մոդելները</a:t>
-            </a:r>
-            <a:endParaRPr lang="ru-RU" dirty="0"/>
-          </a:p>
-        </p:txBody>
-      </p:sp>
-      <p:pic>
-        <p:nvPicPr>
-          <p:cNvPr id="5" name="Picture 2" descr="IaaS vs. PaaS vs. SaaS"/>
-          <p:cNvPicPr>
-            <a:picLocks noChangeAspect="1" noChangeArrowheads="1"/>
-          </p:cNvPicPr>
-          <p:nvPr/>
-        </p:nvPicPr>
-        <p:blipFill>
-          <a:blip r:embed="rId2">
-            <a:extLst>
-              <a:ext uri="{28A0092B-C50C-407E-A947-70E740481C1C}">
-                <a14:useLocalDpi xmlns:a14="http://schemas.microsoft.com/office/drawing/2010/main" val="0"/>
-              </a:ext>
-            </a:extLst>
-          </a:blip>
-          <a:srcRect/>
-          <a:stretch>
-            <a:fillRect/>
-          </a:stretch>
-        </p:blipFill>
-        <p:spPr bwMode="auto">
-          <a:xfrm>
-            <a:off x="2688977" y="1896646"/>
-            <a:ext cx="6814045" cy="4351338"/>
-          </a:xfrm>
-          <a:prstGeom prst="rect">
-            <a:avLst/>
-          </a:prstGeom>
-          <a:noFill/>
-          <a:extLst>
-            <a:ext uri="{909E8E84-426E-40DD-AFC4-6F175D3DCCD1}">
-              <a14:hiddenFill xmlns:a14="http://schemas.microsoft.com/office/drawing/2010/main">
-                <a:solidFill>
-                  <a:srgbClr val="FFFFFF"/>
-                </a:solidFill>
-              </a14:hiddenFill>
-            </a:ext>
-          </a:extLst>
-        </p:spPr>
-      </p:pic>
-    </p:spTree>
-    <p:extLst>
-      <p:ext uri="{BB962C8B-B14F-4D97-AF65-F5344CB8AC3E}">
-        <p14:creationId xmlns:p14="http://schemas.microsoft.com/office/powerpoint/2010/main" val="1361853009"/>
-      </p:ext>
-    </p:extLst>
-  </p:cSld>
-  <p:clrMapOvr>
-    <a:masterClrMapping/>
-  </p:clrMapOvr>
-  <p:timing>
-    <p:tnLst>
-      <p:par>
-        <p:cTn id="1" dur="indefinite" restart="never" nodeType="tmRoot"/>
-      </p:par>
-    </p:tnLst>
-  </p:timing>
-</p:sld>
-</file>
-
-<file path=ppt/slides/slide4.xml><?xml version="1.0" encoding="utf-8"?>
-<p:sld xmlns:a="http://schemas.openxmlformats.org/drawingml/2006/main" xmlns:r="http://schemas.openxmlformats.org/officeDocument/2006/relationships" xmlns:p="http://schemas.openxmlformats.org/presentationml/2006/main">
-  <p:cSld>
-    <p:spTree>
-      <p:nvGrpSpPr>
-        <p:cNvPr id="1" name=""/>
-        <p:cNvGrpSpPr/>
-        <p:nvPr/>
-      </p:nvGrpSpPr>
-      <p:grpSpPr>
-        <a:xfrm>
-          <a:off x="0" y="0"/>
-          <a:ext cx="0" cy="0"/>
-          <a:chOff x="0" y="0"/>
-          <a:chExt cx="0" cy="0"/>
-        </a:xfrm>
-      </p:grpSpPr>
-      <p:sp>
-        <p:nvSpPr>
-          <p:cNvPr id="2" name="Title 1"/>
-          <p:cNvSpPr>
-            <a:spLocks noGrp="1"/>
-          </p:cNvSpPr>
-          <p:nvPr>
-            <p:ph type="title"/>
-          </p:nvPr>
-        </p:nvSpPr>
-        <p:spPr/>
-        <p:txBody>
-          <a:bodyPr/>
-          <a:lstStyle/>
-          <a:p>
-            <a:pPr algn="ctr"/>
-            <a:r>
-              <a:rPr lang="hy-AM" dirty="0" smtClean="0">
-                <a:latin typeface="Stylafen"/>
-              </a:rPr>
-              <a:t>Ամպային Տեխնոլոգիաներ</a:t>
-            </a:r>
-            <a:endParaRPr lang="ru-RU" dirty="0">
-              <a:latin typeface="Stylafen"/>
-            </a:endParaRPr>
-          </a:p>
-        </p:txBody>
-      </p:sp>
-      <p:pic>
-        <p:nvPicPr>
-          <p:cNvPr id="7" name="Content Placeholder 6"/>
-          <p:cNvPicPr>
-            <a:picLocks noGrp="1" noChangeAspect="1"/>
-          </p:cNvPicPr>
-          <p:nvPr>
-            <p:ph idx="1"/>
-          </p:nvPr>
-        </p:nvPicPr>
-        <p:blipFill>
-          <a:blip r:embed="rId2" cstate="print">
-            <a:extLst>
-              <a:ext uri="{28A0092B-C50C-407E-A947-70E740481C1C}">
-                <a14:useLocalDpi xmlns:a14="http://schemas.microsoft.com/office/drawing/2010/main" val="0"/>
-              </a:ext>
-            </a:extLst>
-          </a:blip>
-          <a:stretch>
-            <a:fillRect/>
-          </a:stretch>
-        </p:blipFill>
-        <p:spPr>
-          <a:xfrm>
-            <a:off x="838200" y="2082389"/>
-            <a:ext cx="10515600" cy="3837810"/>
-          </a:xfrm>
-        </p:spPr>
-      </p:pic>
-    </p:spTree>
-    <p:extLst>
-      <p:ext uri="{BB962C8B-B14F-4D97-AF65-F5344CB8AC3E}">
-        <p14:creationId xmlns:p14="http://schemas.microsoft.com/office/powerpoint/2010/main" val="295587833"/>
-      </p:ext>
-    </p:extLst>
-  </p:cSld>
-  <p:clrMapOvr>
-    <a:masterClrMapping/>
-  </p:clrMapOvr>
-  <p:timing>
-    <p:tnLst>
-      <p:par>
-        <p:cTn id="1" dur="indefinite" restart="never" nodeType="tmRoot"/>
-      </p:par>
-    </p:tnLst>
-  </p:timing>
-</p:sld>
-</file>
-
-<file path=ppt/slides/slide5.xml><?xml version="1.0" encoding="utf-8"?>
-<p:sld xmlns:a="http://schemas.openxmlformats.org/drawingml/2006/main" xmlns:r="http://schemas.openxmlformats.org/officeDocument/2006/relationships" xmlns:p="http://schemas.openxmlformats.org/presentationml/2006/main">
-  <p:cSld>
-    <p:spTree>
-      <p:nvGrpSpPr>
-        <p:cNvPr id="1" name=""/>
-        <p:cNvGrpSpPr/>
-        <p:nvPr/>
-      </p:nvGrpSpPr>
-      <p:grpSpPr>
-        <a:xfrm>
-          <a:off x="0" y="0"/>
-          <a:ext cx="0" cy="0"/>
-          <a:chOff x="0" y="0"/>
-          <a:chExt cx="0" cy="0"/>
-        </a:xfrm>
-      </p:grpSpPr>
-      <p:pic>
-        <p:nvPicPr>
-          <p:cNvPr id="6" name="Picture 5"/>
-          <p:cNvPicPr>
-            <a:picLocks noChangeAspect="1"/>
-          </p:cNvPicPr>
-          <p:nvPr/>
-        </p:nvPicPr>
-        <p:blipFill>
-          <a:blip r:embed="rId2">
-            <a:extLst>
-              <a:ext uri="{28A0092B-C50C-407E-A947-70E740481C1C}">
-                <a14:useLocalDpi xmlns:a14="http://schemas.microsoft.com/office/drawing/2010/main" val="0"/>
-              </a:ext>
-            </a:extLst>
-          </a:blip>
-          <a:stretch>
-            <a:fillRect/>
-          </a:stretch>
-        </p:blipFill>
-        <p:spPr>
-          <a:xfrm>
-            <a:off x="-1" y="-1"/>
-            <a:ext cx="6862439" cy="6862439"/>
-          </a:xfrm>
-          <a:prstGeom prst="rect">
-            <a:avLst/>
-          </a:prstGeom>
-        </p:spPr>
-      </p:pic>
-      <p:sp>
-        <p:nvSpPr>
-          <p:cNvPr id="7" name="TextBox 6"/>
-          <p:cNvSpPr txBox="1"/>
-          <p:nvPr/>
-        </p:nvSpPr>
-        <p:spPr>
-          <a:xfrm>
-            <a:off x="8047608" y="3346882"/>
-            <a:ext cx="3129377" cy="400110"/>
-          </a:xfrm>
-          <a:prstGeom prst="rect">
-            <a:avLst/>
-          </a:prstGeom>
-          <a:noFill/>
-        </p:spPr>
-        <p:txBody>
-          <a:bodyPr wrap="square" rtlCol="0">
-            <a:spAutoFit/>
-          </a:bodyPr>
-          <a:lstStyle/>
-          <a:p>
-            <a:r>
-              <a:rPr lang="en-US" sz="2000" dirty="0"/>
-              <a:t>https://</a:t>
-            </a:r>
-            <a:r>
-              <a:rPr lang="en-US" sz="2000" dirty="0" smtClean="0"/>
-              <a:t>www.statista.com</a:t>
-            </a:r>
-            <a:endParaRPr lang="ru-RU" sz="2000" dirty="0"/>
-          </a:p>
-        </p:txBody>
-      </p:sp>
-    </p:spTree>
-    <p:extLst>
-      <p:ext uri="{BB962C8B-B14F-4D97-AF65-F5344CB8AC3E}">
-        <p14:creationId xmlns:p14="http://schemas.microsoft.com/office/powerpoint/2010/main" val="1416974609"/>
-      </p:ext>
-    </p:extLst>
-  </p:cSld>
-  <p:clrMapOvr>
-    <a:masterClrMapping/>
-  </p:clrMapOvr>
-  <p:timing>
-    <p:tnLst>
-      <p:par>
-        <p:cTn id="1" dur="indefinite" restart="never" nodeType="tmRoot"/>
-      </p:par>
-    </p:tnLst>
-  </p:timing>
-</p:sld>
-</file>
-
-<file path=ppt/slides/slide6.xml><?xml version="1.0" encoding="utf-8"?>
-<p:sld xmlns:a="http://schemas.openxmlformats.org/drawingml/2006/main" xmlns:r="http://schemas.openxmlformats.org/officeDocument/2006/relationships" xmlns:p="http://schemas.openxmlformats.org/presentationml/2006/main">
-  <p:cSld>
-    <p:spTree>
-      <p:nvGrpSpPr>
-        <p:cNvPr id="1" name=""/>
-        <p:cNvGrpSpPr/>
-        <p:nvPr/>
-      </p:nvGrpSpPr>
-      <p:grpSpPr>
-        <a:xfrm>
-          <a:off x="0" y="0"/>
-          <a:ext cx="0" cy="0"/>
-          <a:chOff x="0" y="0"/>
-          <a:chExt cx="0" cy="0"/>
-        </a:xfrm>
-      </p:grpSpPr>
-      <p:sp>
-        <p:nvSpPr>
-          <p:cNvPr id="2" name="Title 1"/>
-          <p:cNvSpPr>
-            <a:spLocks noGrp="1"/>
-          </p:cNvSpPr>
-          <p:nvPr>
-            <p:ph type="title"/>
-          </p:nvPr>
-        </p:nvSpPr>
-        <p:spPr>
-          <a:xfrm>
-            <a:off x="838200" y="698508"/>
-            <a:ext cx="10515600" cy="1325563"/>
-          </a:xfrm>
-        </p:spPr>
-        <p:txBody>
-          <a:bodyPr/>
-          <a:lstStyle/>
-          <a:p>
-            <a:pPr algn="ctr"/>
-            <a:r>
-              <a:rPr lang="en-US" dirty="0" smtClean="0">
-                <a:latin typeface="Stylafen"/>
-              </a:rPr>
-              <a:t>OLTP/OLAP </a:t>
-            </a:r>
-            <a:r>
-              <a:rPr lang="hy-AM" dirty="0" smtClean="0">
-                <a:latin typeface="Stylafen"/>
-              </a:rPr>
-              <a:t>համակարգեր</a:t>
-            </a:r>
-            <a:endParaRPr lang="ru-RU" dirty="0">
-              <a:latin typeface="Stylafen"/>
-            </a:endParaRPr>
-          </a:p>
-        </p:txBody>
-      </p:sp>
-      <p:pic>
-        <p:nvPicPr>
-          <p:cNvPr id="3" name="Picture 2"/>
-          <p:cNvPicPr>
-            <a:picLocks noChangeAspect="1"/>
-          </p:cNvPicPr>
-          <p:nvPr/>
-        </p:nvPicPr>
-        <p:blipFill>
-          <a:blip r:embed="rId2"/>
-          <a:stretch>
-            <a:fillRect/>
-          </a:stretch>
-        </p:blipFill>
-        <p:spPr>
-          <a:xfrm>
-            <a:off x="838200" y="2233483"/>
-            <a:ext cx="10450383" cy="3172268"/>
-          </a:xfrm>
-          <a:prstGeom prst="rect">
-            <a:avLst/>
-          </a:prstGeom>
-        </p:spPr>
-      </p:pic>
-    </p:spTree>
-    <p:extLst>
-      <p:ext uri="{BB962C8B-B14F-4D97-AF65-F5344CB8AC3E}">
-        <p14:creationId xmlns:p14="http://schemas.microsoft.com/office/powerpoint/2010/main" val="2068935442"/>
-      </p:ext>
-    </p:extLst>
-  </p:cSld>
-  <p:clrMapOvr>
-    <a:masterClrMapping/>
-  </p:clrMapOvr>
-  <p:timing>
-    <p:tnLst>
-      <p:par>
-        <p:cTn id="1" dur="indefinite" restart="never" nodeType="tmRoot"/>
-      </p:par>
-    </p:tnLst>
-  </p:timing>
-</p:sld>
-</file>
-
-<file path=ppt/slides/slide7.xml><?xml version="1.0" encoding="utf-8"?>
-<p:sld xmlns:a="http://schemas.openxmlformats.org/drawingml/2006/main" xmlns:r="http://schemas.openxmlformats.org/officeDocument/2006/relationships" xmlns:p="http://schemas.openxmlformats.org/presentationml/2006/main">
-  <p:cSld>
-    <p:spTree>
-      <p:nvGrpSpPr>
-        <p:cNvPr id="1" name=""/>
-        <p:cNvGrpSpPr/>
-        <p:nvPr/>
-      </p:nvGrpSpPr>
-      <p:grpSpPr>
-        <a:xfrm>
-          <a:off x="0" y="0"/>
-          <a:ext cx="0" cy="0"/>
-          <a:chOff x="0" y="0"/>
-          <a:chExt cx="0" cy="0"/>
-        </a:xfrm>
-      </p:grpSpPr>
-      <p:sp>
-        <p:nvSpPr>
-          <p:cNvPr id="5" name="TextBox 4"/>
-          <p:cNvSpPr txBox="1"/>
-          <p:nvPr/>
-        </p:nvSpPr>
-        <p:spPr>
-          <a:xfrm>
-            <a:off x="417250" y="337351"/>
-            <a:ext cx="11390051" cy="769441"/>
-          </a:xfrm>
-          <a:prstGeom prst="rect">
-            <a:avLst/>
-          </a:prstGeom>
-          <a:noFill/>
-        </p:spPr>
-        <p:txBody>
-          <a:bodyPr wrap="square" rtlCol="0">
-            <a:spAutoFit/>
-          </a:bodyPr>
-          <a:lstStyle/>
-          <a:p>
-            <a:pPr algn="ctr"/>
-            <a:r>
-              <a:rPr lang="en-US" sz="4400" dirty="0" smtClean="0"/>
-              <a:t>ETL </a:t>
-            </a:r>
-            <a:r>
-              <a:rPr lang="hy-AM" sz="4400" dirty="0" smtClean="0"/>
-              <a:t>և </a:t>
-            </a:r>
-            <a:r>
-              <a:rPr lang="en-US" sz="4400" dirty="0" smtClean="0"/>
-              <a:t>ELT</a:t>
-            </a:r>
-            <a:r>
-              <a:rPr lang="hy-AM" sz="4400" dirty="0"/>
-              <a:t> </a:t>
-            </a:r>
-            <a:r>
-              <a:rPr lang="hy-AM" sz="4400" dirty="0" smtClean="0"/>
-              <a:t>տվյալների ինտեգրման եղանակներ</a:t>
-            </a:r>
-            <a:endParaRPr lang="ru-RU" sz="4400" dirty="0"/>
-          </a:p>
-        </p:txBody>
-      </p:sp>
-      <p:pic>
-        <p:nvPicPr>
-          <p:cNvPr id="2" name="Picture 1"/>
-          <p:cNvPicPr>
-            <a:picLocks noChangeAspect="1"/>
-          </p:cNvPicPr>
-          <p:nvPr/>
-        </p:nvPicPr>
-        <p:blipFill>
-          <a:blip r:embed="rId2"/>
-          <a:stretch>
-            <a:fillRect/>
-          </a:stretch>
-        </p:blipFill>
-        <p:spPr>
-          <a:xfrm>
-            <a:off x="1201452" y="1204195"/>
-            <a:ext cx="9821646" cy="4982270"/>
-          </a:xfrm>
-          <a:prstGeom prst="rect">
-            <a:avLst/>
-          </a:prstGeom>
-        </p:spPr>
-      </p:pic>
-    </p:spTree>
-    <p:extLst>
-      <p:ext uri="{BB962C8B-B14F-4D97-AF65-F5344CB8AC3E}">
-        <p14:creationId xmlns:p14="http://schemas.microsoft.com/office/powerpoint/2010/main" val="948259556"/>
-      </p:ext>
-    </p:extLst>
-  </p:cSld>
-  <p:clrMapOvr>
-    <a:masterClrMapping/>
-  </p:clrMapOvr>
-  <p:timing>
-    <p:tnLst>
-      <p:par>
-        <p:cTn id="1" dur="indefinite" restart="never" nodeType="tmRoot"/>
-      </p:par>
-    </p:tnLst>
-  </p:timing>
-</p:sld>
-</file>
-
-<file path=ppt/slides/slide8.xml><?xml version="1.0" encoding="utf-8"?>
-<p:sld xmlns:a="http://schemas.openxmlformats.org/drawingml/2006/main" xmlns:r="http://schemas.openxmlformats.org/officeDocument/2006/relationships" xmlns:p="http://schemas.openxmlformats.org/presentationml/2006/main">
-  <p:cSld>
-    <p:spTree>
-      <p:nvGrpSpPr>
-        <p:cNvPr id="1" name=""/>
-        <p:cNvGrpSpPr/>
-        <p:nvPr/>
-      </p:nvGrpSpPr>
-      <p:grpSpPr>
-        <a:xfrm>
-          <a:off x="0" y="0"/>
-          <a:ext cx="0" cy="0"/>
-          <a:chOff x="0" y="0"/>
-          <a:chExt cx="0" cy="0"/>
-        </a:xfrm>
-      </p:grpSpPr>
-      <p:sp>
-        <p:nvSpPr>
-          <p:cNvPr id="2" name="Title 1"/>
-          <p:cNvSpPr>
-            <a:spLocks noGrp="1"/>
-          </p:cNvSpPr>
-          <p:nvPr>
-            <p:ph type="title"/>
-          </p:nvPr>
-        </p:nvSpPr>
-        <p:spPr>
-          <a:xfrm>
-            <a:off x="820444" y="107673"/>
-            <a:ext cx="10515600" cy="1325563"/>
-          </a:xfrm>
-        </p:spPr>
-        <p:txBody>
-          <a:bodyPr/>
-          <a:lstStyle/>
-          <a:p>
-            <a:pPr algn="ctr"/>
-            <a:r>
-              <a:rPr lang="hy-AM" dirty="0" smtClean="0">
-                <a:latin typeface="Stylafen"/>
-              </a:rPr>
-              <a:t>Մեդալիոն </a:t>
-            </a:r>
-            <a:r>
-              <a:rPr lang="hy-AM" dirty="0" smtClean="0">
-                <a:latin typeface="Stylafen"/>
-              </a:rPr>
-              <a:t>Ճարտարապետություն</a:t>
-            </a:r>
-            <a:endParaRPr lang="ru-RU" dirty="0">
-              <a:latin typeface="Stylafen"/>
-            </a:endParaRPr>
-          </a:p>
-        </p:txBody>
-      </p:sp>
-      <p:pic>
-        <p:nvPicPr>
-          <p:cNvPr id="6" name="Picture 5"/>
-          <p:cNvPicPr>
-            <a:picLocks noChangeAspect="1"/>
-          </p:cNvPicPr>
-          <p:nvPr/>
-        </p:nvPicPr>
-        <p:blipFill>
-          <a:blip r:embed="rId2"/>
-          <a:stretch>
-            <a:fillRect/>
-          </a:stretch>
-        </p:blipFill>
-        <p:spPr>
-          <a:xfrm>
-            <a:off x="310717" y="1530113"/>
-            <a:ext cx="11137363" cy="4533336"/>
-          </a:xfrm>
-          <a:prstGeom prst="rect">
-            <a:avLst/>
-          </a:prstGeom>
-        </p:spPr>
-      </p:pic>
-    </p:spTree>
-    <p:extLst>
-      <p:ext uri="{BB962C8B-B14F-4D97-AF65-F5344CB8AC3E}">
-        <p14:creationId xmlns:p14="http://schemas.microsoft.com/office/powerpoint/2010/main" val="3398836416"/>
-      </p:ext>
-    </p:extLst>
-  </p:cSld>
-  <p:clrMapOvr>
-    <a:masterClrMapping/>
-  </p:clrMapOvr>
-  <p:timing>
-    <p:tnLst>
-      <p:par>
-        <p:cTn id="1" dur="indefinite" restart="never" nodeType="tmRoot"/>
-      </p:par>
-    </p:tnLst>
-  </p:timing>
-</p:sld>
-</file>
-
-<file path=ppt/slides/slide9.xml><?xml version="1.0" encoding="utf-8"?>
-<p:sld xmlns:a="http://schemas.openxmlformats.org/drawingml/2006/main" xmlns:r="http://schemas.openxmlformats.org/officeDocument/2006/relationships" xmlns:p="http://schemas.openxmlformats.org/presentationml/2006/main">
-  <p:cSld>
-    <p:spTree>
-      <p:nvGrpSpPr>
-        <p:cNvPr id="1" name=""/>
-        <p:cNvGrpSpPr/>
-        <p:nvPr/>
-      </p:nvGrpSpPr>
-      <p:grpSpPr>
-        <a:xfrm>
-          <a:off x="0" y="0"/>
-          <a:ext cx="0" cy="0"/>
-          <a:chOff x="0" y="0"/>
-          <a:chExt cx="0" cy="0"/>
-        </a:xfrm>
-      </p:grpSpPr>
-      <p:sp>
-        <p:nvSpPr>
-          <p:cNvPr id="2" name="Title 1"/>
-          <p:cNvSpPr>
-            <a:spLocks noGrp="1"/>
-          </p:cNvSpPr>
-          <p:nvPr>
-            <p:ph type="title"/>
-          </p:nvPr>
-        </p:nvSpPr>
-        <p:spPr>
-          <a:xfrm>
-            <a:off x="1352614" y="365125"/>
-            <a:ext cx="6929761" cy="1325563"/>
-          </a:xfrm>
-        </p:spPr>
-        <p:txBody>
-          <a:bodyPr/>
-          <a:lstStyle/>
-          <a:p>
-            <a:pPr algn="ctr"/>
-            <a:r>
-              <a:rPr lang="en-US" dirty="0" smtClean="0">
-                <a:latin typeface="Stylafen"/>
-              </a:rPr>
-              <a:t>Azure Data Factory (ADF)</a:t>
-            </a:r>
-            <a:endParaRPr lang="ru-RU" dirty="0">
-              <a:latin typeface="Stylafen"/>
-            </a:endParaRPr>
-          </a:p>
-        </p:txBody>
-      </p:sp>
-      <p:pic>
-        <p:nvPicPr>
-          <p:cNvPr id="4" name="Content Placeholder 3"/>
-          <p:cNvPicPr>
-            <a:picLocks noGrp="1" noChangeAspect="1"/>
-          </p:cNvPicPr>
-          <p:nvPr>
-            <p:ph idx="1"/>
-          </p:nvPr>
-        </p:nvPicPr>
-        <p:blipFill>
-          <a:blip r:embed="rId2" cstate="print">
-            <a:extLst>
-              <a:ext uri="{28A0092B-C50C-407E-A947-70E740481C1C}">
-                <a14:useLocalDpi xmlns:a14="http://schemas.microsoft.com/office/drawing/2010/main" val="0"/>
-              </a:ext>
-            </a:extLst>
-          </a:blip>
-          <a:stretch>
-            <a:fillRect/>
-          </a:stretch>
-        </p:blipFill>
-        <p:spPr>
-          <a:xfrm>
-            <a:off x="1352614" y="1905524"/>
-            <a:ext cx="8936358" cy="4351338"/>
-          </a:xfrm>
-        </p:spPr>
-      </p:pic>
-      <p:pic>
-        <p:nvPicPr>
-          <p:cNvPr id="7" name="Picture 6"/>
-          <p:cNvPicPr>
-            <a:picLocks noChangeAspect="1"/>
-          </p:cNvPicPr>
-          <p:nvPr/>
-        </p:nvPicPr>
-        <p:blipFill>
-          <a:blip r:embed="rId3"/>
-          <a:stretch>
-            <a:fillRect/>
-          </a:stretch>
-        </p:blipFill>
-        <p:spPr>
-          <a:xfrm>
-            <a:off x="8522240" y="632804"/>
-            <a:ext cx="905846" cy="905846"/>
-          </a:xfrm>
-          <a:prstGeom prst="rect">
-            <a:avLst/>
-          </a:prstGeom>
-        </p:spPr>
-      </p:pic>
-    </p:spTree>
-    <p:extLst>
-      <p:ext uri="{BB962C8B-B14F-4D97-AF65-F5344CB8AC3E}">
-        <p14:creationId xmlns:p14="http://schemas.microsoft.com/office/powerpoint/2010/main" val="2407570629"/>
       </p:ext>
     </p:extLst>
   </p:cSld>

</xml_diff>